<commit_message>
Correct C2 residual candidate labels in Final decks
Co-authored-by: Cursor <cursoragent@cursor.com>
</commit_message>
<xml_diff>
--- a/ppt/PP-X_Final_Research_Detailed_v2.pptx
+++ b/ppt/PP-X_Final_Research_Detailed_v2.pptx
@@ -8199,2776 +8199,6 @@
 </p:sld>
 </file>
 
-<file path=ppt/slides/slide13.xml><?xml version="1.0" encoding="utf-8"?>
-<p:sld xmlns:a="http://schemas.openxmlformats.org/drawingml/2006/main" xmlns:p="http://schemas.openxmlformats.org/presentationml/2006/main" xmlns:r="http://schemas.openxmlformats.org/officeDocument/2006/relationships">
-  <p:cSld>
-    <p:spTree>
-      <p:nvGrpSpPr>
-        <p:cNvPr id="1" name=""/>
-        <p:cNvGrpSpPr/>
-        <p:nvPr/>
-      </p:nvGrpSpPr>
-      <p:grpSpPr/>
-      <p:sp>
-        <p:nvSpPr>
-          <p:cNvPr id="2" name="Rectangle 1"/>
-          <p:cNvSpPr/>
-          <p:nvPr/>
-        </p:nvSpPr>
-        <p:spPr>
-          <a:xfrm>
-            <a:off x="0" y="0"/>
-            <a:ext cx="12192000" cy="6858000"/>
-          </a:xfrm>
-          <a:prstGeom prst="rect">
-            <a:avLst/>
-          </a:prstGeom>
-          <a:solidFill>
-            <a:srgbClr val="FFFFFF"/>
-          </a:solidFill>
-          <a:ln>
-            <a:noFill/>
-          </a:ln>
-        </p:spPr>
-        <p:style>
-          <a:lnRef idx="1">
-            <a:schemeClr val="accent1"/>
-          </a:lnRef>
-          <a:fillRef idx="3">
-            <a:schemeClr val="accent1"/>
-          </a:fillRef>
-          <a:effectRef idx="2">
-            <a:schemeClr val="accent1"/>
-          </a:effectRef>
-          <a:fontRef idx="minor">
-            <a:schemeClr val="lt1"/>
-          </a:fontRef>
-        </p:style>
-        <p:txBody>
-          <a:bodyPr rtlCol="0" anchor="ctr"/>
-          <a:lstStyle/>
-          <a:p>
-            <a:pPr algn="ctr"/>
-          </a:p>
-        </p:txBody>
-      </p:sp>
-      <p:sp>
-        <p:nvSpPr>
-          <p:cNvPr id="3" name="Rectangle 2"/>
-          <p:cNvSpPr/>
-          <p:nvPr/>
-        </p:nvSpPr>
-        <p:spPr>
-          <a:xfrm>
-            <a:off x="0" y="0"/>
-            <a:ext cx="12192000" cy="19050"/>
-          </a:xfrm>
-          <a:prstGeom prst="rect">
-            <a:avLst/>
-          </a:prstGeom>
-          <a:solidFill>
-            <a:srgbClr val="222222"/>
-          </a:solidFill>
-          <a:ln>
-            <a:noFill/>
-          </a:ln>
-        </p:spPr>
-        <p:style>
-          <a:lnRef idx="1">
-            <a:schemeClr val="accent1"/>
-          </a:lnRef>
-          <a:fillRef idx="3">
-            <a:schemeClr val="accent1"/>
-          </a:fillRef>
-          <a:effectRef idx="2">
-            <a:schemeClr val="accent1"/>
-          </a:effectRef>
-          <a:fontRef idx="minor">
-            <a:schemeClr val="lt1"/>
-          </a:fontRef>
-        </p:style>
-        <p:txBody>
-          <a:bodyPr rtlCol="0" anchor="ctr"/>
-          <a:lstStyle/>
-          <a:p>
-            <a:pPr algn="ctr"/>
-          </a:p>
-        </p:txBody>
-      </p:sp>
-      <p:sp>
-        <p:nvSpPr>
-          <p:cNvPr id="4" name="TextBox 3"/>
-          <p:cNvSpPr txBox="1"/>
-          <p:nvPr/>
-        </p:nvSpPr>
-        <p:spPr>
-          <a:xfrm>
-            <a:off x="457200" y="209550"/>
-            <a:ext cx="11239500" cy="304800"/>
-          </a:xfrm>
-          <a:prstGeom prst="rect">
-            <a:avLst/>
-          </a:prstGeom>
-          <a:noFill/>
-        </p:spPr>
-        <p:txBody>
-          <a:bodyPr wrap="square">
-            <a:spAutoFit/>
-          </a:bodyPr>
-          <a:lstStyle/>
-          <a:p>
-            <a:pPr algn="l"/>
-            <a:r>
-              <a:rPr sz="2200" b="1">
-                <a:solidFill>
-                  <a:srgbClr val="222222"/>
-                </a:solidFill>
-                <a:latin typeface="Arial"/>
-                <a:ea typeface="AppleGothic"/>
-              </a:rPr>
-              <a:t>프로토콜</a:t>
-            </a:r>
-          </a:p>
-        </p:txBody>
-      </p:sp>
-      <p:sp>
-        <p:nvSpPr>
-          <p:cNvPr id="5" name="TextBox 4"/>
-          <p:cNvSpPr txBox="1"/>
-          <p:nvPr/>
-        </p:nvSpPr>
-        <p:spPr>
-          <a:xfrm>
-            <a:off x="457200" y="514350"/>
-            <a:ext cx="11239500" cy="190500"/>
-          </a:xfrm>
-          <a:prstGeom prst="rect">
-            <a:avLst/>
-          </a:prstGeom>
-          <a:noFill/>
-        </p:spPr>
-        <p:txBody>
-          <a:bodyPr wrap="square">
-            <a:spAutoFit/>
-          </a:bodyPr>
-          <a:lstStyle/>
-          <a:p>
-            <a:pPr algn="l"/>
-            <a:r>
-              <a:rPr sz="1200" b="0">
-                <a:solidFill>
-                  <a:srgbClr val="666666"/>
-                </a:solidFill>
-                <a:latin typeface="Arial"/>
-                <a:ea typeface="AppleGothic"/>
-              </a:rPr>
-              <a:t>점수는 이 범위 안에서만 읽는다  ·  적합도는 허가증이지 성적표가 아니다</a:t>
-            </a:r>
-          </a:p>
-        </p:txBody>
-      </p:sp>
-      <p:graphicFrame>
-        <p:nvGraphicFramePr>
-          <p:cNvPr id="6" name="Table 5"/>
-          <p:cNvGraphicFramePr>
-            <a:graphicFrameLocks noGrp="1"/>
-          </p:cNvGraphicFramePr>
-          <p:nvPr/>
-        </p:nvGraphicFramePr>
-        <p:xfrm>
-          <a:off x="457200" y="952500"/>
-          <a:ext cx="11277600" cy="2381250"/>
-        </p:xfrm>
-        <a:graphic>
-          <a:graphicData uri="http://schemas.openxmlformats.org/drawingml/2006/table">
-            <a:tbl>
-              <a:tblPr firstRow="1" bandRow="1">
-                <a:tableStyleId>{5C22544A-7EE6-4342-B048-85BDC9FD1C3A}</a:tableStyleId>
-              </a:tblPr>
-              <a:tblGrid>
-                <a:gridCol w="3759200"/>
-                <a:gridCol w="3759200"/>
-                <a:gridCol w="3759200"/>
-              </a:tblGrid>
-              <a:tr h="476250">
-                <a:tc>
-                  <a:txBody>
-                    <a:bodyPr/>
-                    <a:lstStyle/>
-                    <a:p>
-                      <a:pPr algn="ctr"/>
-                      <a:r>
-                        <a:rPr sz="1300" b="1">
-                          <a:solidFill>
-                            <a:srgbClr val="FFFFFF"/>
-                          </a:solidFill>
-                          <a:latin typeface="Arial"/>
-                          <a:ea typeface="AppleGothic"/>
-                        </a:rPr>
-                        <a:t>규칙</a:t>
-                      </a:r>
-                    </a:p>
-                  </a:txBody>
-                  <a:tcPr anchor="ctr">
-                    <a:solidFill>
-                      <a:srgbClr val="222222"/>
-                    </a:solidFill>
-                  </a:tcPr>
-                </a:tc>
-                <a:tc>
-                  <a:txBody>
-                    <a:bodyPr/>
-                    <a:lstStyle/>
-                    <a:p>
-                      <a:pPr algn="ctr"/>
-                      <a:r>
-                        <a:rPr sz="1300" b="1">
-                          <a:solidFill>
-                            <a:srgbClr val="FFFFFF"/>
-                          </a:solidFill>
-                          <a:latin typeface="Arial"/>
-                          <a:ea typeface="AppleGothic"/>
-                        </a:rPr>
-                        <a:t>의미</a:t>
-                      </a:r>
-                    </a:p>
-                  </a:txBody>
-                  <a:tcPr anchor="ctr">
-                    <a:solidFill>
-                      <a:srgbClr val="222222"/>
-                    </a:solidFill>
-                  </a:tcPr>
-                </a:tc>
-                <a:tc>
-                  <a:txBody>
-                    <a:bodyPr/>
-                    <a:lstStyle/>
-                    <a:p>
-                      <a:pPr algn="ctr"/>
-                      <a:r>
-                        <a:rPr sz="1300" b="1">
-                          <a:solidFill>
-                            <a:srgbClr val="FFFFFF"/>
-                          </a:solidFill>
-                          <a:latin typeface="Arial"/>
-                          <a:ea typeface="AppleGothic"/>
-                        </a:rPr>
-                        <a:t>깨지면</a:t>
-                      </a:r>
-                    </a:p>
-                  </a:txBody>
-                  <a:tcPr anchor="ctr">
-                    <a:solidFill>
-                      <a:srgbClr val="222222"/>
-                    </a:solidFill>
-                  </a:tcPr>
-                </a:tc>
-              </a:tr>
-              <a:tr h="476250">
-                <a:tc>
-                  <a:txBody>
-                    <a:bodyPr/>
-                    <a:lstStyle/>
-                    <a:p>
-                      <a:pPr algn="l"/>
-                      <a:r>
-                        <a:rPr sz="1300" b="1">
-                          <a:solidFill>
-                            <a:srgbClr val="222222"/>
-                          </a:solidFill>
-                          <a:latin typeface="Arial"/>
-                          <a:ea typeface="AppleGothic"/>
-                        </a:rPr>
-                        <a:t>unit-disjoint</a:t>
-                      </a:r>
-                    </a:p>
-                  </a:txBody>
-                  <a:tcPr anchor="ctr">
-                    <a:solidFill>
-                      <a:srgbClr val="FFFFFF"/>
-                    </a:solidFill>
-                  </a:tcPr>
-                </a:tc>
-                <a:tc>
-                  <a:txBody>
-                    <a:bodyPr/>
-                    <a:lstStyle/>
-                    <a:p>
-                      <a:pPr algn="ctr"/>
-                      <a:r>
-                        <a:rPr sz="1300" b="0">
-                          <a:solidFill>
-                            <a:srgbClr val="222222"/>
-                          </a:solidFill>
-                          <a:latin typeface="Arial"/>
-                          <a:ea typeface="AppleGothic"/>
-                        </a:rPr>
-                        <a:t>train / val / test 셀이 겹치지 않음</a:t>
-                      </a:r>
-                    </a:p>
-                  </a:txBody>
-                  <a:tcPr anchor="ctr">
-                    <a:solidFill>
-                      <a:srgbClr val="FFFFFF"/>
-                    </a:solidFill>
-                  </a:tcPr>
-                </a:tc>
-                <a:tc>
-                  <a:txBody>
-                    <a:bodyPr/>
-                    <a:lstStyle/>
-                    <a:p>
-                      <a:pPr algn="ctr"/>
-                      <a:r>
-                        <a:rPr sz="1300" b="0">
-                          <a:solidFill>
-                            <a:srgbClr val="222222"/>
-                          </a:solidFill>
-                          <a:latin typeface="Arial"/>
-                          <a:ea typeface="AppleGothic"/>
-                        </a:rPr>
-                        <a:t>같은 유닛 누수</a:t>
-                      </a:r>
-                    </a:p>
-                  </a:txBody>
-                  <a:tcPr anchor="ctr">
-                    <a:solidFill>
-                      <a:srgbClr val="FFFFFF"/>
-                    </a:solidFill>
-                  </a:tcPr>
-                </a:tc>
-              </a:tr>
-              <a:tr h="476250">
-                <a:tc>
-                  <a:txBody>
-                    <a:bodyPr/>
-                    <a:lstStyle/>
-                    <a:p>
-                      <a:pPr algn="l"/>
-                      <a:r>
-                        <a:rPr sz="1300" b="1">
-                          <a:solidFill>
-                            <a:srgbClr val="222222"/>
-                          </a:solidFill>
-                          <a:latin typeface="Arial"/>
-                          <a:ea typeface="AppleGothic"/>
-                        </a:rPr>
-                        <a:t>hull-out</a:t>
-                      </a:r>
-                    </a:p>
-                  </a:txBody>
-                  <a:tcPr anchor="ctr">
-                    <a:solidFill>
-                      <a:srgbClr val="F5F5F5"/>
-                    </a:solidFill>
-                  </a:tcPr>
-                </a:tc>
-                <a:tc>
-                  <a:txBody>
-                    <a:bodyPr/>
-                    <a:lstStyle/>
-                    <a:p>
-                      <a:pPr algn="ctr"/>
-                      <a:r>
-                        <a:rPr sz="1300" b="0">
-                          <a:solidFill>
-                            <a:srgbClr val="222222"/>
-                          </a:solidFill>
-                          <a:latin typeface="Arial"/>
-                          <a:ea typeface="AppleGothic"/>
-                        </a:rPr>
-                        <a:t>선언한 1D 열화좌표에서 test가 train 밖</a:t>
-                      </a:r>
-                    </a:p>
-                  </a:txBody>
-                  <a:tcPr anchor="ctr">
-                    <a:solidFill>
-                      <a:srgbClr val="F5F5F5"/>
-                    </a:solidFill>
-                  </a:tcPr>
-                </a:tc>
-                <a:tc>
-                  <a:txBody>
-                    <a:bodyPr/>
-                    <a:lstStyle/>
-                    <a:p>
-                      <a:pPr algn="ctr"/>
-                      <a:r>
-                        <a:rPr sz="1300" b="0">
-                          <a:solidFill>
-                            <a:srgbClr val="222222"/>
-                          </a:solidFill>
-                          <a:latin typeface="Arial"/>
-                          <a:ea typeface="AppleGothic"/>
-                        </a:rPr>
-                        <a:t>내삽으로 바뀜</a:t>
-                      </a:r>
-                    </a:p>
-                  </a:txBody>
-                  <a:tcPr anchor="ctr">
-                    <a:solidFill>
-                      <a:srgbClr val="F5F5F5"/>
-                    </a:solidFill>
-                  </a:tcPr>
-                </a:tc>
-              </a:tr>
-              <a:tr h="476250">
-                <a:tc>
-                  <a:txBody>
-                    <a:bodyPr/>
-                    <a:lstStyle/>
-                    <a:p>
-                      <a:pPr algn="l"/>
-                      <a:r>
-                        <a:rPr sz="1300" b="1">
-                          <a:solidFill>
-                            <a:srgbClr val="222222"/>
-                          </a:solidFill>
-                          <a:latin typeface="Arial"/>
-                          <a:ea typeface="AppleGothic"/>
-                        </a:rPr>
-                        <a:t>val-only</a:t>
-                      </a:r>
-                    </a:p>
-                  </a:txBody>
-                  <a:tcPr anchor="ctr">
-                    <a:solidFill>
-                      <a:srgbClr val="FFFFFF"/>
-                    </a:solidFill>
-                  </a:tcPr>
-                </a:tc>
-                <a:tc>
-                  <a:txBody>
-                    <a:bodyPr/>
-                    <a:lstStyle/>
-                    <a:p>
-                      <a:pPr algn="ctr"/>
-                      <a:r>
-                        <a:rPr sz="1300" b="0">
-                          <a:solidFill>
-                            <a:srgbClr val="222222"/>
-                          </a:solidFill>
-                          <a:latin typeface="Arial"/>
-                          <a:ea typeface="AppleGothic"/>
-                        </a:rPr>
-                        <a:t>게이트·보정을 val에서만 고름</a:t>
-                      </a:r>
-                    </a:p>
-                  </a:txBody>
-                  <a:tcPr anchor="ctr">
-                    <a:solidFill>
-                      <a:srgbClr val="FFFFFF"/>
-                    </a:solidFill>
-                  </a:tcPr>
-                </a:tc>
-                <a:tc>
-                  <a:txBody>
-                    <a:bodyPr/>
-                    <a:lstStyle/>
-                    <a:p>
-                      <a:pPr algn="ctr"/>
-                      <a:r>
-                        <a:rPr sz="1300" b="0">
-                          <a:solidFill>
-                            <a:srgbClr val="222222"/>
-                          </a:solidFill>
-                          <a:latin typeface="Arial"/>
-                          <a:ea typeface="AppleGothic"/>
-                        </a:rPr>
-                        <a:t>test로 튜닝</a:t>
-                      </a:r>
-                    </a:p>
-                  </a:txBody>
-                  <a:tcPr anchor="ctr">
-                    <a:solidFill>
-                      <a:srgbClr val="FFFFFF"/>
-                    </a:solidFill>
-                  </a:tcPr>
-                </a:tc>
-              </a:tr>
-              <a:tr h="476250">
-                <a:tc>
-                  <a:txBody>
-                    <a:bodyPr/>
-                    <a:lstStyle/>
-                    <a:p>
-                      <a:pPr algn="l"/>
-                      <a:r>
-                        <a:rPr sz="1300" b="1">
-                          <a:solidFill>
-                            <a:srgbClr val="222222"/>
-                          </a:solidFill>
-                          <a:latin typeface="Arial"/>
-                          <a:ea typeface="AppleGothic"/>
-                        </a:rPr>
-                        <a:t>Pass / Weak / Fail</a:t>
-                      </a:r>
-                    </a:p>
-                  </a:txBody>
-                  <a:tcPr anchor="ctr">
-                    <a:solidFill>
-                      <a:srgbClr val="F5F5F5"/>
-                    </a:solidFill>
-                  </a:tcPr>
-                </a:tc>
-                <a:tc>
-                  <a:txBody>
-                    <a:bodyPr/>
-                    <a:lstStyle/>
-                    <a:p>
-                      <a:pPr algn="ctr"/>
-                      <a:r>
-                        <a:rPr sz="1300" b="0">
-                          <a:solidFill>
-                            <a:srgbClr val="222222"/>
-                          </a:solidFill>
-                          <a:latin typeface="Arial"/>
-                          <a:ea typeface="AppleGothic"/>
-                        </a:rPr>
-                        <a:t>운행 허가. Fail이면 예측을 옮기지 않음</a:t>
-                      </a:r>
-                    </a:p>
-                  </a:txBody>
-                  <a:tcPr anchor="ctr">
-                    <a:solidFill>
-                      <a:srgbClr val="F5F5F5"/>
-                    </a:solidFill>
-                  </a:tcPr>
-                </a:tc>
-                <a:tc>
-                  <a:txBody>
-                    <a:bodyPr/>
-                    <a:lstStyle/>
-                    <a:p>
-                      <a:pPr algn="ctr"/>
-                      <a:r>
-                        <a:rPr sz="1300" b="0">
-                          <a:solidFill>
-                            <a:srgbClr val="222222"/>
-                          </a:solidFill>
-                          <a:latin typeface="Arial"/>
-                          <a:ea typeface="AppleGothic"/>
-                        </a:rPr>
-                        <a:t>억지 점수</a:t>
-                      </a:r>
-                    </a:p>
-                  </a:txBody>
-                  <a:tcPr anchor="ctr">
-                    <a:solidFill>
-                      <a:srgbClr val="F5F5F5"/>
-                    </a:solidFill>
-                  </a:tcPr>
-                </a:tc>
-              </a:tr>
-            </a:tbl>
-          </a:graphicData>
-        </a:graphic>
-      </p:graphicFrame>
-      <p:graphicFrame>
-        <p:nvGraphicFramePr>
-          <p:cNvPr id="7" name="Table 6"/>
-          <p:cNvGraphicFramePr>
-            <a:graphicFrameLocks noGrp="1"/>
-          </p:cNvGraphicFramePr>
-          <p:nvPr/>
-        </p:nvGraphicFramePr>
-        <p:xfrm>
-          <a:off x="457200" y="3619500"/>
-          <a:ext cx="5524500" cy="2095500"/>
-        </p:xfrm>
-        <a:graphic>
-          <a:graphicData uri="http://schemas.openxmlformats.org/drawingml/2006/table">
-            <a:tbl>
-              <a:tblPr firstRow="1" bandRow="1">
-                <a:tableStyleId>{5C22544A-7EE6-4342-B048-85BDC9FD1C3A}</a:tableStyleId>
-              </a:tblPr>
-              <a:tblGrid>
-                <a:gridCol w="2762250"/>
-                <a:gridCol w="2762250"/>
-              </a:tblGrid>
-              <a:tr h="523875">
-                <a:tc>
-                  <a:txBody>
-                    <a:bodyPr/>
-                    <a:lstStyle/>
-                    <a:p>
-                      <a:pPr algn="ctr"/>
-                      <a:r>
-                        <a:rPr sz="1200" b="1">
-                          <a:solidFill>
-                            <a:srgbClr val="FFFFFF"/>
-                          </a:solidFill>
-                          <a:latin typeface="Arial"/>
-                          <a:ea typeface="AppleGothic"/>
-                        </a:rPr>
-                        <a:t>In scope</a:t>
-                      </a:r>
-                    </a:p>
-                  </a:txBody>
-                  <a:tcPr anchor="ctr">
-                    <a:solidFill>
-                      <a:srgbClr val="222222"/>
-                    </a:solidFill>
-                  </a:tcPr>
-                </a:tc>
-                <a:tc>
-                  <a:txBody>
-                    <a:bodyPr/>
-                    <a:lstStyle/>
-                    <a:p>
-                      <a:pPr algn="ctr"/>
-                      <a:r>
-                        <a:rPr sz="1200" b="1">
-                          <a:solidFill>
-                            <a:srgbClr val="FFFFFF"/>
-                          </a:solidFill>
-                          <a:latin typeface="Arial"/>
-                          <a:ea typeface="AppleGothic"/>
-                        </a:rPr>
-                        <a:t>예</a:t>
-                      </a:r>
-                    </a:p>
-                  </a:txBody>
-                  <a:tcPr anchor="ctr">
-                    <a:solidFill>
-                      <a:srgbClr val="222222"/>
-                    </a:solidFill>
-                  </a:tcPr>
-                </a:tc>
-              </a:tr>
-              <a:tr h="523875">
-                <a:tc>
-                  <a:txBody>
-                    <a:bodyPr/>
-                    <a:lstStyle/>
-                    <a:p>
-                      <a:pPr algn="l"/>
-                      <a:r>
-                        <a:rPr sz="1200" b="1">
-                          <a:solidFill>
-                            <a:srgbClr val="222222"/>
-                          </a:solidFill>
-                          <a:latin typeface="Arial"/>
-                          <a:ea typeface="AppleGothic"/>
-                        </a:rPr>
-                        <a:t>1D late-tail</a:t>
-                      </a:r>
-                    </a:p>
-                  </a:txBody>
-                  <a:tcPr anchor="ctr">
-                    <a:solidFill>
-                      <a:srgbClr val="FFFFFF"/>
-                    </a:solidFill>
-                  </a:tcPr>
-                </a:tc>
-                <a:tc>
-                  <a:txBody>
-                    <a:bodyPr/>
-                    <a:lstStyle/>
-                    <a:p>
-                      <a:pPr algn="ctr"/>
-                      <a:r>
-                        <a:rPr sz="1200" b="0">
-                          <a:solidFill>
-                            <a:srgbClr val="222222"/>
-                          </a:solidFill>
-                          <a:latin typeface="Arial"/>
-                          <a:ea typeface="AppleGothic"/>
-                        </a:rPr>
-                        <a:t>Sun · RWTH · MICH · MATR2019 · NASA · Virkler · HUST</a:t>
-                      </a:r>
-                    </a:p>
-                  </a:txBody>
-                  <a:tcPr anchor="ctr">
-                    <a:solidFill>
-                      <a:srgbClr val="FFFFFF"/>
-                    </a:solidFill>
-                  </a:tcPr>
-                </a:tc>
-              </a:tr>
-              <a:tr h="523875">
-                <a:tc>
-                  <a:txBody>
-                    <a:bodyPr/>
-                    <a:lstStyle/>
-                    <a:p>
-                      <a:pPr algn="l"/>
-                      <a:r>
-                        <a:rPr sz="1200" b="1">
-                          <a:solidFill>
-                            <a:srgbClr val="222222"/>
-                          </a:solidFill>
-                          <a:latin typeface="Arial"/>
-                          <a:ea typeface="AppleGothic"/>
-                        </a:rPr>
-                        <a:t>1D + 다차원 설명 필요</a:t>
-                      </a:r>
-                    </a:p>
-                  </a:txBody>
-                  <a:tcPr anchor="ctr">
-                    <a:solidFill>
-                      <a:srgbClr val="F5F5F5"/>
-                    </a:solidFill>
-                  </a:tcPr>
-                </a:tc>
-                <a:tc>
-                  <a:txBody>
-                    <a:bodyPr/>
-                    <a:lstStyle/>
-                    <a:p>
-                      <a:pPr algn="ctr"/>
-                      <a:r>
-                        <a:rPr sz="1200" b="0">
-                          <a:solidFill>
-                            <a:srgbClr val="222222"/>
-                          </a:solidFill>
-                          <a:latin typeface="Arial"/>
-                          <a:ea typeface="AppleGothic"/>
-                        </a:rPr>
-                        <a:t>MATRb2 · N-CMAPSS (PCA2는 0%)</a:t>
-                      </a:r>
-                    </a:p>
-                  </a:txBody>
-                  <a:tcPr anchor="ctr">
-                    <a:solidFill>
-                      <a:srgbClr val="F5F5F5"/>
-                    </a:solidFill>
-                  </a:tcPr>
-                </a:tc>
-              </a:tr>
-              <a:tr h="523875">
-                <a:tc>
-                  <a:txBody>
-                    <a:bodyPr/>
-                    <a:lstStyle/>
-                    <a:p>
-                      <a:pPr algn="l"/>
-                      <a:r>
-                        <a:rPr sz="1200" b="1">
-                          <a:solidFill>
-                            <a:srgbClr val="222222"/>
-                          </a:solidFill>
-                          <a:latin typeface="Arial"/>
-                          <a:ea typeface="AppleGothic"/>
-                        </a:rPr>
-                        <a:t>executor 선택</a:t>
-                      </a:r>
-                    </a:p>
-                  </a:txBody>
-                  <a:tcPr anchor="ctr">
-                    <a:solidFill>
-                      <a:srgbClr val="FFFFFF"/>
-                    </a:solidFill>
-                  </a:tcPr>
-                </a:tc>
-                <a:tc>
-                  <a:txBody>
-                    <a:bodyPr/>
-                    <a:lstStyle/>
-                    <a:p>
-                      <a:pPr algn="ctr"/>
-                      <a:r>
-                        <a:rPr sz="1200" b="0">
-                          <a:solidFill>
-                            <a:srgbClr val="222222"/>
-                          </a:solidFill>
-                          <a:latin typeface="Arial"/>
-                          <a:ea typeface="AppleGothic"/>
-                        </a:rPr>
-                        <a:t>train/val · group-LOO only</a:t>
-                      </a:r>
-                    </a:p>
-                  </a:txBody>
-                  <a:tcPr anchor="ctr">
-                    <a:solidFill>
-                      <a:srgbClr val="FFFFFF"/>
-                    </a:solidFill>
-                  </a:tcPr>
-                </a:tc>
-              </a:tr>
-            </a:tbl>
-          </a:graphicData>
-        </a:graphic>
-      </p:graphicFrame>
-      <p:graphicFrame>
-        <p:nvGraphicFramePr>
-          <p:cNvPr id="8" name="Table 7"/>
-          <p:cNvGraphicFramePr>
-            <a:graphicFrameLocks noGrp="1"/>
-          </p:cNvGraphicFramePr>
-          <p:nvPr/>
-        </p:nvGraphicFramePr>
-        <p:xfrm>
-          <a:off x="6210300" y="3619500"/>
-          <a:ext cx="5524500" cy="2095500"/>
-        </p:xfrm>
-        <a:graphic>
-          <a:graphicData uri="http://schemas.openxmlformats.org/drawingml/2006/table">
-            <a:tbl>
-              <a:tblPr firstRow="1" bandRow="1">
-                <a:tableStyleId>{5C22544A-7EE6-4342-B048-85BDC9FD1C3A}</a:tableStyleId>
-              </a:tblPr>
-              <a:tblGrid>
-                <a:gridCol w="2762250"/>
-                <a:gridCol w="2762250"/>
-              </a:tblGrid>
-              <a:tr h="523875">
-                <a:tc>
-                  <a:txBody>
-                    <a:bodyPr/>
-                    <a:lstStyle/>
-                    <a:p>
-                      <a:pPr algn="ctr"/>
-                      <a:r>
-                        <a:rPr sz="1200" b="1">
-                          <a:solidFill>
-                            <a:srgbClr val="FFFFFF"/>
-                          </a:solidFill>
-                          <a:latin typeface="Arial"/>
-                          <a:ea typeface="AppleGothic"/>
-                        </a:rPr>
-                        <a:t>오늘 표에 없음</a:t>
-                      </a:r>
-                    </a:p>
-                  </a:txBody>
-                  <a:tcPr anchor="ctr">
-                    <a:solidFill>
-                      <a:srgbClr val="222222"/>
-                    </a:solidFill>
-                  </a:tcPr>
-                </a:tc>
-                <a:tc>
-                  <a:txBody>
-                    <a:bodyPr/>
-                    <a:lstStyle/>
-                    <a:p>
-                      <a:pPr algn="ctr"/>
-                      <a:r>
-                        <a:rPr sz="1200" b="1">
-                          <a:solidFill>
-                            <a:srgbClr val="FFFFFF"/>
-                          </a:solidFill>
-                          <a:latin typeface="Arial"/>
-                          <a:ea typeface="AppleGothic"/>
-                        </a:rPr>
-                        <a:t>이유</a:t>
-                      </a:r>
-                    </a:p>
-                  </a:txBody>
-                  <a:tcPr anchor="ctr">
-                    <a:solidFill>
-                      <a:srgbClr val="222222"/>
-                    </a:solidFill>
-                  </a:tcPr>
-                </a:tc>
-              </a:tr>
-              <a:tr h="523875">
-                <a:tc>
-                  <a:txBody>
-                    <a:bodyPr/>
-                    <a:lstStyle/>
-                    <a:p>
-                      <a:pPr algn="l"/>
-                      <a:r>
-                        <a:rPr sz="1200" b="1">
-                          <a:solidFill>
-                            <a:srgbClr val="222222"/>
-                          </a:solidFill>
-                          <a:latin typeface="Arial"/>
-                          <a:ea typeface="AppleGothic"/>
-                        </a:rPr>
-                        <a:t>전체 feature hull</a:t>
-                      </a:r>
-                    </a:p>
-                  </a:txBody>
-                  <a:tcPr anchor="ctr">
-                    <a:solidFill>
-                      <a:srgbClr val="FFFFFF"/>
-                    </a:solidFill>
-                  </a:tcPr>
-                </a:tc>
-                <a:tc>
-                  <a:txBody>
-                    <a:bodyPr/>
-                    <a:lstStyle/>
-                    <a:p>
-                      <a:pPr algn="ctr"/>
-                      <a:r>
-                        <a:rPr sz="1200" b="0">
-                          <a:solidFill>
-                            <a:srgbClr val="222222"/>
-                          </a:solidFill>
-                          <a:latin typeface="Arial"/>
-                          <a:ea typeface="AppleGothic"/>
-                        </a:rPr>
-                        <a:t>1D 100% ≠ 다차원 hull 밖</a:t>
-                      </a:r>
-                    </a:p>
-                  </a:txBody>
-                  <a:tcPr anchor="ctr">
-                    <a:solidFill>
-                      <a:srgbClr val="FFFFFF"/>
-                    </a:solidFill>
-                  </a:tcPr>
-                </a:tc>
-              </a:tr>
-              <a:tr h="523875">
-                <a:tc>
-                  <a:txBody>
-                    <a:bodyPr/>
-                    <a:lstStyle/>
-                    <a:p>
-                      <a:pPr algn="l"/>
-                      <a:r>
-                        <a:rPr sz="1200" b="1">
-                          <a:solidFill>
-                            <a:srgbClr val="222222"/>
-                          </a:solidFill>
-                          <a:latin typeface="Arial"/>
-                          <a:ea typeface="AppleGothic"/>
-                        </a:rPr>
-                        <a:t>도메인 / 재료 transfer</a:t>
-                      </a:r>
-                    </a:p>
-                  </a:txBody>
-                  <a:tcPr anchor="ctr">
-                    <a:solidFill>
-                      <a:srgbClr val="F5F5F5"/>
-                    </a:solidFill>
-                  </a:tcPr>
-                </a:tc>
-                <a:tc>
-                  <a:txBody>
-                    <a:bodyPr/>
-                    <a:lstStyle/>
-                    <a:p>
-                      <a:pPr algn="ctr"/>
-                      <a:r>
-                        <a:rPr sz="1200" b="0">
-                          <a:solidFill>
-                            <a:srgbClr val="222222"/>
-                          </a:solidFill>
-                          <a:latin typeface="Arial"/>
-                          <a:ea typeface="AppleGothic"/>
-                        </a:rPr>
-                        <a:t>조건·끝점·재질 이동은 다른 종류</a:t>
-                      </a:r>
-                    </a:p>
-                  </a:txBody>
-                  <a:tcPr anchor="ctr">
-                    <a:solidFill>
-                      <a:srgbClr val="F5F5F5"/>
-                    </a:solidFill>
-                  </a:tcPr>
-                </a:tc>
-              </a:tr>
-              <a:tr h="523875">
-                <a:tc>
-                  <a:txBody>
-                    <a:bodyPr/>
-                    <a:lstStyle/>
-                    <a:p>
-                      <a:pPr algn="l"/>
-                      <a:r>
-                        <a:rPr sz="1200" b="1">
-                          <a:solidFill>
-                            <a:srgbClr val="222222"/>
-                          </a:solidFill>
-                          <a:latin typeface="Arial"/>
-                          <a:ea typeface="AppleGothic"/>
-                        </a:rPr>
-                        <a:t>C-MAPSS FD002/004</a:t>
-                      </a:r>
-                    </a:p>
-                  </a:txBody>
-                  <a:tcPr anchor="ctr">
-                    <a:solidFill>
-                      <a:srgbClr val="FFFFFF"/>
-                    </a:solidFill>
-                  </a:tcPr>
-                </a:tc>
-                <a:tc>
-                  <a:txBody>
-                    <a:bodyPr/>
-                    <a:lstStyle/>
-                    <a:p>
-                      <a:pPr algn="ctr"/>
-                      <a:r>
-                        <a:rPr sz="1200" b="0">
-                          <a:solidFill>
-                            <a:srgbClr val="222222"/>
-                          </a:solidFill>
-                          <a:latin typeface="Arial"/>
-                          <a:ea typeface="AppleGothic"/>
-                        </a:rPr>
-                        <a:t>조건 hull은 강하나 이번 주표 밖</a:t>
-                      </a:r>
-                    </a:p>
-                  </a:txBody>
-                  <a:tcPr anchor="ctr">
-                    <a:solidFill>
-                      <a:srgbClr val="FFFFFF"/>
-                    </a:solidFill>
-                  </a:tcPr>
-                </a:tc>
-              </a:tr>
-            </a:tbl>
-          </a:graphicData>
-        </a:graphic>
-      </p:graphicFrame>
-      <p:cxnSp>
-        <p:nvCxnSpPr>
-          <p:cNvPr id="9" name="Connector 8"/>
-          <p:cNvCxnSpPr/>
-          <p:nvPr/>
-        </p:nvCxnSpPr>
-        <p:spPr>
-          <a:xfrm>
-            <a:off x="457200" y="6477000"/>
-            <a:ext cx="11277600" cy="0"/>
-          </a:xfrm>
-          <a:prstGeom prst="line">
-            <a:avLst/>
-          </a:prstGeom>
-          <a:ln w="9525">
-            <a:solidFill>
-              <a:srgbClr val="E8E8E8"/>
-            </a:solidFill>
-          </a:ln>
-        </p:spPr>
-        <p:style>
-          <a:lnRef idx="2">
-            <a:schemeClr val="accent1"/>
-          </a:lnRef>
-          <a:fillRef idx="0">
-            <a:schemeClr val="accent1"/>
-          </a:fillRef>
-          <a:effectRef idx="1">
-            <a:schemeClr val="accent1"/>
-          </a:effectRef>
-          <a:fontRef idx="minor">
-            <a:schemeClr val="tx1"/>
-          </a:fontRef>
-        </p:style>
-      </p:cxnSp>
-      <p:sp>
-        <p:nvSpPr>
-          <p:cNvPr id="10" name="TextBox 9"/>
-          <p:cNvSpPr txBox="1"/>
-          <p:nvPr/>
-        </p:nvSpPr>
-        <p:spPr>
-          <a:xfrm>
-            <a:off x="457200" y="6534150"/>
-            <a:ext cx="7620000" cy="133350"/>
-          </a:xfrm>
-          <a:prstGeom prst="rect">
-            <a:avLst/>
-          </a:prstGeom>
-          <a:noFill/>
-        </p:spPr>
-        <p:txBody>
-          <a:bodyPr wrap="square">
-            <a:spAutoFit/>
-          </a:bodyPr>
-          <a:lstStyle/>
-          <a:p>
-            <a:pPr algn="l"/>
-            <a:r>
-              <a:rPr sz="900" b="0">
-                <a:solidFill>
-                  <a:srgbClr val="666666"/>
-                </a:solidFill>
-                <a:latin typeface="Arial"/>
-                <a:ea typeface="AppleGothic"/>
-              </a:rPr>
-              <a:t>SPS Lab  ·  Prior-Adaptive Extrapolation  ·  PP-X</a:t>
-            </a:r>
-          </a:p>
-        </p:txBody>
-      </p:sp>
-      <p:sp>
-        <p:nvSpPr>
-          <p:cNvPr id="11" name="TextBox 10"/>
-          <p:cNvSpPr txBox="1"/>
-          <p:nvPr/>
-        </p:nvSpPr>
-        <p:spPr>
-          <a:xfrm>
-            <a:off x="10477500" y="6515100"/>
-            <a:ext cx="952500" cy="152400"/>
-          </a:xfrm>
-          <a:prstGeom prst="rect">
-            <a:avLst/>
-          </a:prstGeom>
-          <a:noFill/>
-        </p:spPr>
-        <p:txBody>
-          <a:bodyPr wrap="square">
-            <a:spAutoFit/>
-          </a:bodyPr>
-          <a:lstStyle/>
-          <a:p>
-            <a:pPr algn="r"/>
-            <a:r>
-              <a:rPr sz="1000" b="1">
-                <a:solidFill>
-                  <a:srgbClr val="666666"/>
-                </a:solidFill>
-                <a:latin typeface="Arial"/>
-                <a:ea typeface="AppleGothic"/>
-              </a:rPr>
-              <a:t>13/42</a:t>
-            </a:r>
-          </a:p>
-        </p:txBody>
-      </p:sp>
-    </p:spTree>
-  </p:cSld>
-  <p:clrMapOvr>
-    <a:masterClrMapping/>
-  </p:clrMapOvr>
-</p:sld>
-</file>
-
-<file path=ppt/slides/slide14.xml><?xml version="1.0" encoding="utf-8"?>
-<p:sld xmlns:a="http://schemas.openxmlformats.org/drawingml/2006/main" xmlns:p="http://schemas.openxmlformats.org/presentationml/2006/main" xmlns:r="http://schemas.openxmlformats.org/officeDocument/2006/relationships">
-  <p:cSld>
-    <p:spTree>
-      <p:nvGrpSpPr>
-        <p:cNvPr id="1" name=""/>
-        <p:cNvGrpSpPr/>
-        <p:nvPr/>
-      </p:nvGrpSpPr>
-      <p:grpSpPr/>
-      <p:sp>
-        <p:nvSpPr>
-          <p:cNvPr id="2" name="Rectangle 1"/>
-          <p:cNvSpPr/>
-          <p:nvPr/>
-        </p:nvSpPr>
-        <p:spPr>
-          <a:xfrm>
-            <a:off x="0" y="0"/>
-            <a:ext cx="12192000" cy="6858000"/>
-          </a:xfrm>
-          <a:prstGeom prst="rect">
-            <a:avLst/>
-          </a:prstGeom>
-          <a:solidFill>
-            <a:srgbClr val="FFFFFF"/>
-          </a:solidFill>
-          <a:ln>
-            <a:noFill/>
-          </a:ln>
-        </p:spPr>
-        <p:style>
-          <a:lnRef idx="1">
-            <a:schemeClr val="accent1"/>
-          </a:lnRef>
-          <a:fillRef idx="3">
-            <a:schemeClr val="accent1"/>
-          </a:fillRef>
-          <a:effectRef idx="2">
-            <a:schemeClr val="accent1"/>
-          </a:effectRef>
-          <a:fontRef idx="minor">
-            <a:schemeClr val="lt1"/>
-          </a:fontRef>
-        </p:style>
-        <p:txBody>
-          <a:bodyPr rtlCol="0" anchor="ctr"/>
-          <a:lstStyle/>
-          <a:p>
-            <a:pPr algn="ctr"/>
-          </a:p>
-        </p:txBody>
-      </p:sp>
-      <p:sp>
-        <p:nvSpPr>
-          <p:cNvPr id="3" name="Rectangle 2"/>
-          <p:cNvSpPr/>
-          <p:nvPr/>
-        </p:nvSpPr>
-        <p:spPr>
-          <a:xfrm>
-            <a:off x="0" y="0"/>
-            <a:ext cx="12192000" cy="19050"/>
-          </a:xfrm>
-          <a:prstGeom prst="rect">
-            <a:avLst/>
-          </a:prstGeom>
-          <a:solidFill>
-            <a:srgbClr val="222222"/>
-          </a:solidFill>
-          <a:ln>
-            <a:noFill/>
-          </a:ln>
-        </p:spPr>
-        <p:style>
-          <a:lnRef idx="1">
-            <a:schemeClr val="accent1"/>
-          </a:lnRef>
-          <a:fillRef idx="3">
-            <a:schemeClr val="accent1"/>
-          </a:fillRef>
-          <a:effectRef idx="2">
-            <a:schemeClr val="accent1"/>
-          </a:effectRef>
-          <a:fontRef idx="minor">
-            <a:schemeClr val="lt1"/>
-          </a:fontRef>
-        </p:style>
-        <p:txBody>
-          <a:bodyPr rtlCol="0" anchor="ctr"/>
-          <a:lstStyle/>
-          <a:p>
-            <a:pPr algn="ctr"/>
-          </a:p>
-        </p:txBody>
-      </p:sp>
-      <p:sp>
-        <p:nvSpPr>
-          <p:cNvPr id="4" name="TextBox 3"/>
-          <p:cNvSpPr txBox="1"/>
-          <p:nvPr/>
-        </p:nvSpPr>
-        <p:spPr>
-          <a:xfrm>
-            <a:off x="457200" y="209550"/>
-            <a:ext cx="11239500" cy="304800"/>
-          </a:xfrm>
-          <a:prstGeom prst="rect">
-            <a:avLst/>
-          </a:prstGeom>
-          <a:noFill/>
-        </p:spPr>
-        <p:txBody>
-          <a:bodyPr wrap="square">
-            <a:spAutoFit/>
-          </a:bodyPr>
-          <a:lstStyle/>
-          <a:p>
-            <a:pPr algn="l"/>
-            <a:r>
-              <a:rPr sz="2200" b="1">
-                <a:solidFill>
-                  <a:srgbClr val="222222"/>
-                </a:solidFill>
-                <a:latin typeface="Arial"/>
-                <a:ea typeface="AppleGothic"/>
-              </a:rPr>
-              <a:t>주 결과 — 최종 PP-X portfolio</a:t>
-            </a:r>
-          </a:p>
-        </p:txBody>
-      </p:sp>
-      <p:sp>
-        <p:nvSpPr>
-          <p:cNvPr id="5" name="TextBox 4"/>
-          <p:cNvSpPr txBox="1"/>
-          <p:nvPr/>
-        </p:nvSpPr>
-        <p:spPr>
-          <a:xfrm>
-            <a:off x="457200" y="514350"/>
-            <a:ext cx="11239500" cy="190500"/>
-          </a:xfrm>
-          <a:prstGeom prst="rect">
-            <a:avLst/>
-          </a:prstGeom>
-          <a:noFill/>
-        </p:spPr>
-        <p:txBody>
-          <a:bodyPr wrap="square">
-            <a:spAutoFit/>
-          </a:bodyPr>
-          <a:lstStyle/>
-          <a:p>
-            <a:pPr algn="l"/>
-            <a:r>
-              <a:rPr sz="1200" b="0">
-                <a:solidFill>
-                  <a:srgbClr val="666666"/>
-                </a:solidFill>
-                <a:latin typeface="Arial"/>
-                <a:ea typeface="AppleGothic"/>
-              </a:rPr>
-              <a:t>1D 열화좌표 기준의 엄격한 외삽만.  retrospective development 결과  ·  PAE 없음</a:t>
-            </a:r>
-          </a:p>
-        </p:txBody>
-      </p:sp>
-      <p:pic>
-        <p:nvPicPr>
-          <p:cNvPr id="6" name="Picture 5" descr="ppx_portfolio.png"/>
-          <p:cNvPicPr>
-            <a:picLocks noChangeAspect="1"/>
-          </p:cNvPicPr>
-          <p:nvPr/>
-        </p:nvPicPr>
-        <p:blipFill>
-          <a:blip r:embed="rId2"/>
-          <a:stretch>
-            <a:fillRect/>
-          </a:stretch>
-        </p:blipFill>
-        <p:spPr>
-          <a:xfrm>
-            <a:off x="285750" y="781050"/>
-            <a:ext cx="6477000" cy="3714750"/>
-          </a:xfrm>
-          <a:prstGeom prst="rect">
-            <a:avLst/>
-          </a:prstGeom>
-        </p:spPr>
-      </p:pic>
-      <p:graphicFrame>
-        <p:nvGraphicFramePr>
-          <p:cNvPr id="7" name="Table 6"/>
-          <p:cNvGraphicFramePr>
-            <a:graphicFrameLocks noGrp="1"/>
-          </p:cNvGraphicFramePr>
-          <p:nvPr/>
-        </p:nvGraphicFramePr>
-        <p:xfrm>
-          <a:off x="6858000" y="838200"/>
-          <a:ext cx="4876800" cy="3657600"/>
-        </p:xfrm>
-        <a:graphic>
-          <a:graphicData uri="http://schemas.openxmlformats.org/drawingml/2006/table">
-            <a:tbl>
-              <a:tblPr firstRow="1" bandRow="1">
-                <a:tableStyleId>{5C22544A-7EE6-4342-B048-85BDC9FD1C3A}</a:tableStyleId>
-              </a:tblPr>
-              <a:tblGrid>
-                <a:gridCol w="1625600"/>
-                <a:gridCol w="1625600"/>
-                <a:gridCol w="1625600"/>
-              </a:tblGrid>
-              <a:tr h="365760">
-                <a:tc>
-                  <a:txBody>
-                    <a:bodyPr/>
-                    <a:lstStyle/>
-                    <a:p>
-                      <a:pPr algn="ctr"/>
-                      <a:r>
-                        <a:rPr sz="1000" b="1">
-                          <a:solidFill>
-                            <a:srgbClr val="FFFFFF"/>
-                          </a:solidFill>
-                          <a:latin typeface="Arial"/>
-                          <a:ea typeface="AppleGothic"/>
-                        </a:rPr>
-                        <a:t>셋</a:t>
-                      </a:r>
-                    </a:p>
-                  </a:txBody>
-                  <a:tcPr anchor="ctr">
-                    <a:solidFill>
-                      <a:srgbClr val="222222"/>
-                    </a:solidFill>
-                  </a:tcPr>
-                </a:tc>
-                <a:tc>
-                  <a:txBody>
-                    <a:bodyPr/>
-                    <a:lstStyle/>
-                    <a:p>
-                      <a:pPr algn="ctr"/>
-                      <a:r>
-                        <a:rPr sz="1000" b="1">
-                          <a:solidFill>
-                            <a:srgbClr val="FFFFFF"/>
-                          </a:solidFill>
-                          <a:latin typeface="Arial"/>
-                          <a:ea typeface="AppleGothic"/>
-                        </a:rPr>
-                        <a:t>Executor</a:t>
-                      </a:r>
-                    </a:p>
-                  </a:txBody>
-                  <a:tcPr anchor="ctr">
-                    <a:solidFill>
-                      <a:srgbClr val="222222"/>
-                    </a:solidFill>
-                  </a:tcPr>
-                </a:tc>
-                <a:tc>
-                  <a:txBody>
-                    <a:bodyPr/>
-                    <a:lstStyle/>
-                    <a:p>
-                      <a:pPr algn="ctr"/>
-                      <a:r>
-                        <a:rPr sz="1000" b="1">
-                          <a:solidFill>
-                            <a:srgbClr val="FFFFFF"/>
-                          </a:solidFill>
-                          <a:latin typeface="Arial"/>
-                          <a:ea typeface="AppleGothic"/>
-                        </a:rPr>
-                        <a:t>R²</a:t>
-                      </a:r>
-                    </a:p>
-                  </a:txBody>
-                  <a:tcPr anchor="ctr">
-                    <a:solidFill>
-                      <a:srgbClr val="222222"/>
-                    </a:solidFill>
-                  </a:tcPr>
-                </a:tc>
-              </a:tr>
-              <a:tr h="365760">
-                <a:tc>
-                  <a:txBody>
-                    <a:bodyPr/>
-                    <a:lstStyle/>
-                    <a:p>
-                      <a:pPr algn="l"/>
-                      <a:r>
-                        <a:rPr sz="1000" b="1">
-                          <a:solidFill>
-                            <a:srgbClr val="222222"/>
-                          </a:solidFill>
-                          <a:latin typeface="Arial"/>
-                          <a:ea typeface="AppleGothic"/>
-                        </a:rPr>
-                        <a:t>화중 배터리</a:t>
-                      </a:r>
-                    </a:p>
-                  </a:txBody>
-                  <a:tcPr anchor="ctr">
-                    <a:solidFill>
-                      <a:srgbClr val="FFFFFF"/>
-                    </a:solidFill>
-                  </a:tcPr>
-                </a:tc>
-                <a:tc>
-                  <a:txBody>
-                    <a:bodyPr/>
-                    <a:lstStyle/>
-                    <a:p>
-                      <a:pPr algn="ctr"/>
-                      <a:r>
-                        <a:rPr sz="1000" b="0">
-                          <a:solidFill>
-                            <a:srgbClr val="222222"/>
-                          </a:solidFill>
-                          <a:latin typeface="Arial"/>
-                          <a:ea typeface="AppleGothic"/>
-                        </a:rPr>
-                        <a:t>transport</a:t>
-                      </a:r>
-                    </a:p>
-                  </a:txBody>
-                  <a:tcPr anchor="ctr">
-                    <a:solidFill>
-                      <a:srgbClr val="FFFFFF"/>
-                    </a:solidFill>
-                  </a:tcPr>
-                </a:tc>
-                <a:tc>
-                  <a:txBody>
-                    <a:bodyPr/>
-                    <a:lstStyle/>
-                    <a:p>
-                      <a:pPr algn="ctr"/>
-                      <a:r>
-                        <a:rPr sz="1000" b="0">
-                          <a:solidFill>
-                            <a:srgbClr val="222222"/>
-                          </a:solidFill>
-                          <a:latin typeface="Arial"/>
-                          <a:ea typeface="AppleGothic"/>
-                        </a:rPr>
-                        <a:t>0.958</a:t>
-                      </a:r>
-                    </a:p>
-                  </a:txBody>
-                  <a:tcPr anchor="ctr">
-                    <a:solidFill>
-                      <a:srgbClr val="FFFFFF"/>
-                    </a:solidFill>
-                  </a:tcPr>
-                </a:tc>
-              </a:tr>
-              <a:tr h="365760">
-                <a:tc>
-                  <a:txBody>
-                    <a:bodyPr/>
-                    <a:lstStyle/>
-                    <a:p>
-                      <a:pPr algn="l"/>
-                      <a:r>
-                        <a:rPr sz="1000" b="1">
-                          <a:solidFill>
-                            <a:srgbClr val="222222"/>
-                          </a:solidFill>
-                          <a:latin typeface="Arial"/>
-                          <a:ea typeface="AppleGothic"/>
-                        </a:rPr>
-                        <a:t>선우다 상용셀</a:t>
-                      </a:r>
-                    </a:p>
-                  </a:txBody>
-                  <a:tcPr anchor="ctr">
-                    <a:solidFill>
-                      <a:srgbClr val="F5F5F5"/>
-                    </a:solidFill>
-                  </a:tcPr>
-                </a:tc>
-                <a:tc>
-                  <a:txBody>
-                    <a:bodyPr/>
-                    <a:lstStyle/>
-                    <a:p>
-                      <a:pPr algn="ctr"/>
-                      <a:r>
-                        <a:rPr sz="1000" b="0">
-                          <a:solidFill>
-                            <a:srgbClr val="222222"/>
-                          </a:solidFill>
-                          <a:latin typeface="Arial"/>
-                          <a:ea typeface="AppleGothic"/>
-                        </a:rPr>
-                        <a:t>fixed BQ</a:t>
-                      </a:r>
-                    </a:p>
-                  </a:txBody>
-                  <a:tcPr anchor="ctr">
-                    <a:solidFill>
-                      <a:srgbClr val="F5F5F5"/>
-                    </a:solidFill>
-                  </a:tcPr>
-                </a:tc>
-                <a:tc>
-                  <a:txBody>
-                    <a:bodyPr/>
-                    <a:lstStyle/>
-                    <a:p>
-                      <a:pPr algn="ctr"/>
-                      <a:r>
-                        <a:rPr sz="1000" b="0">
-                          <a:solidFill>
-                            <a:srgbClr val="222222"/>
-                          </a:solidFill>
-                          <a:latin typeface="Arial"/>
-                          <a:ea typeface="AppleGothic"/>
-                        </a:rPr>
-                        <a:t>0.939</a:t>
-                      </a:r>
-                    </a:p>
-                  </a:txBody>
-                  <a:tcPr anchor="ctr">
-                    <a:solidFill>
-                      <a:srgbClr val="F5F5F5"/>
-                    </a:solidFill>
-                  </a:tcPr>
-                </a:tc>
-              </a:tr>
-              <a:tr h="365760">
-                <a:tc>
-                  <a:txBody>
-                    <a:bodyPr/>
-                    <a:lstStyle/>
-                    <a:p>
-                      <a:pPr algn="l"/>
-                      <a:r>
-                        <a:rPr sz="1000" b="1">
-                          <a:solidFill>
-                            <a:srgbClr val="222222"/>
-                          </a:solidFill>
-                          <a:latin typeface="Arial"/>
-                          <a:ea typeface="AppleGothic"/>
-                        </a:rPr>
-                        <a:t>항공기 엔진</a:t>
-                      </a:r>
-                    </a:p>
-                  </a:txBody>
-                  <a:tcPr anchor="ctr">
-                    <a:solidFill>
-                      <a:srgbClr val="FFFFFF"/>
-                    </a:solidFill>
-                  </a:tcPr>
-                </a:tc>
-                <a:tc>
-                  <a:txBody>
-                    <a:bodyPr/>
-                    <a:lstStyle/>
-                    <a:p>
-                      <a:pPr algn="ctr"/>
-                      <a:r>
-                        <a:rPr sz="1000" b="0">
-                          <a:solidFill>
-                            <a:srgbClr val="222222"/>
-                          </a:solidFill>
-                          <a:latin typeface="Arial"/>
-                          <a:ea typeface="AppleGothic"/>
-                        </a:rPr>
-                        <a:t>multiscale</a:t>
-                      </a:r>
-                    </a:p>
-                  </a:txBody>
-                  <a:tcPr anchor="ctr">
-                    <a:solidFill>
-                      <a:srgbClr val="FFFFFF"/>
-                    </a:solidFill>
-                  </a:tcPr>
-                </a:tc>
-                <a:tc>
-                  <a:txBody>
-                    <a:bodyPr/>
-                    <a:lstStyle/>
-                    <a:p>
-                      <a:pPr algn="ctr"/>
-                      <a:r>
-                        <a:rPr sz="1000" b="0">
-                          <a:solidFill>
-                            <a:srgbClr val="222222"/>
-                          </a:solidFill>
-                          <a:latin typeface="Arial"/>
-                          <a:ea typeface="AppleGothic"/>
-                        </a:rPr>
-                        <a:t>0.937</a:t>
-                      </a:r>
-                    </a:p>
-                  </a:txBody>
-                  <a:tcPr anchor="ctr">
-                    <a:solidFill>
-                      <a:srgbClr val="FFFFFF"/>
-                    </a:solidFill>
-                  </a:tcPr>
-                </a:tc>
-              </a:tr>
-              <a:tr h="365760">
-                <a:tc>
-                  <a:txBody>
-                    <a:bodyPr/>
-                    <a:lstStyle/>
-                    <a:p>
-                      <a:pPr algn="l"/>
-                      <a:r>
-                        <a:rPr sz="1000" b="1">
-                          <a:solidFill>
-                            <a:srgbClr val="222222"/>
-                          </a:solidFill>
-                          <a:latin typeface="Arial"/>
-                          <a:ea typeface="AppleGothic"/>
-                        </a:rPr>
-                        <a:t>알루미늄 균열</a:t>
-                      </a:r>
-                    </a:p>
-                  </a:txBody>
-                  <a:tcPr anchor="ctr">
-                    <a:solidFill>
-                      <a:srgbClr val="F5F5F5"/>
-                    </a:solidFill>
-                  </a:tcPr>
-                </a:tc>
-                <a:tc>
-                  <a:txBody>
-                    <a:bodyPr/>
-                    <a:lstStyle/>
-                    <a:p>
-                      <a:pPr algn="ctr"/>
-                      <a:r>
-                        <a:rPr sz="1000" b="0">
-                          <a:solidFill>
-                            <a:srgbClr val="222222"/>
-                          </a:solidFill>
-                          <a:latin typeface="Arial"/>
-                          <a:ea typeface="AppleGothic"/>
-                        </a:rPr>
-                        <a:t>gated residual</a:t>
-                      </a:r>
-                    </a:p>
-                  </a:txBody>
-                  <a:tcPr anchor="ctr">
-                    <a:solidFill>
-                      <a:srgbClr val="F5F5F5"/>
-                    </a:solidFill>
-                  </a:tcPr>
-                </a:tc>
-                <a:tc>
-                  <a:txBody>
-                    <a:bodyPr/>
-                    <a:lstStyle/>
-                    <a:p>
-                      <a:pPr algn="ctr"/>
-                      <a:r>
-                        <a:rPr sz="1000" b="0">
-                          <a:solidFill>
-                            <a:srgbClr val="222222"/>
-                          </a:solidFill>
-                          <a:latin typeface="Arial"/>
-                          <a:ea typeface="AppleGothic"/>
-                        </a:rPr>
-                        <a:t>0.888</a:t>
-                      </a:r>
-                    </a:p>
-                  </a:txBody>
-                  <a:tcPr anchor="ctr">
-                    <a:solidFill>
-                      <a:srgbClr val="F5F5F5"/>
-                    </a:solidFill>
-                  </a:tcPr>
-                </a:tc>
-              </a:tr>
-              <a:tr h="365760">
-                <a:tc>
-                  <a:txBody>
-                    <a:bodyPr/>
-                    <a:lstStyle/>
-                    <a:p>
-                      <a:pPr algn="l"/>
-                      <a:r>
-                        <a:rPr sz="1000" b="1">
-                          <a:solidFill>
-                            <a:srgbClr val="222222"/>
-                          </a:solidFill>
-                          <a:latin typeface="Arial"/>
-                          <a:ea typeface="AppleGothic"/>
-                        </a:rPr>
-                        <a:t>아헨 배터리</a:t>
-                      </a:r>
-                    </a:p>
-                  </a:txBody>
-                  <a:tcPr anchor="ctr">
-                    <a:solidFill>
-                      <a:srgbClr val="FFFFFF"/>
-                    </a:solidFill>
-                  </a:tcPr>
-                </a:tc>
-                <a:tc>
-                  <a:txBody>
-                    <a:bodyPr/>
-                    <a:lstStyle/>
-                    <a:p>
-                      <a:pPr algn="ctr"/>
-                      <a:r>
-                        <a:rPr sz="1000" b="0">
-                          <a:solidFill>
-                            <a:srgbClr val="222222"/>
-                          </a:solidFill>
-                          <a:latin typeface="Arial"/>
-                          <a:ea typeface="AppleGothic"/>
-                        </a:rPr>
-                        <a:t>fixed BQ</a:t>
-                      </a:r>
-                    </a:p>
-                  </a:txBody>
-                  <a:tcPr anchor="ctr">
-                    <a:solidFill>
-                      <a:srgbClr val="FFFFFF"/>
-                    </a:solidFill>
-                  </a:tcPr>
-                </a:tc>
-                <a:tc>
-                  <a:txBody>
-                    <a:bodyPr/>
-                    <a:lstStyle/>
-                    <a:p>
-                      <a:pPr algn="ctr"/>
-                      <a:r>
-                        <a:rPr sz="1000" b="0">
-                          <a:solidFill>
-                            <a:srgbClr val="222222"/>
-                          </a:solidFill>
-                          <a:latin typeface="Arial"/>
-                          <a:ea typeface="AppleGothic"/>
-                        </a:rPr>
-                        <a:t>0.878</a:t>
-                      </a:r>
-                    </a:p>
-                  </a:txBody>
-                  <a:tcPr anchor="ctr">
-                    <a:solidFill>
-                      <a:srgbClr val="FFFFFF"/>
-                    </a:solidFill>
-                  </a:tcPr>
-                </a:tc>
-              </a:tr>
-              <a:tr h="365760">
-                <a:tc>
-                  <a:txBody>
-                    <a:bodyPr/>
-                    <a:lstStyle/>
-                    <a:p>
-                      <a:pPr algn="l"/>
-                      <a:r>
-                        <a:rPr sz="1000" b="1">
-                          <a:solidFill>
-                            <a:srgbClr val="222222"/>
-                          </a:solidFill>
-                          <a:latin typeface="Arial"/>
-                          <a:ea typeface="AppleGothic"/>
-                        </a:rPr>
-                        <a:t>MIT 배치2</a:t>
-                      </a:r>
-                    </a:p>
-                  </a:txBody>
-                  <a:tcPr anchor="ctr">
-                    <a:solidFill>
-                      <a:srgbClr val="F5F5F5"/>
-                    </a:solidFill>
-                  </a:tcPr>
-                </a:tc>
-                <a:tc>
-                  <a:txBody>
-                    <a:bodyPr/>
-                    <a:lstStyle/>
-                    <a:p>
-                      <a:pPr algn="ctr"/>
-                      <a:r>
-                        <a:rPr sz="1000" b="0">
-                          <a:solidFill>
-                            <a:srgbClr val="222222"/>
-                          </a:solidFill>
-                          <a:latin typeface="Arial"/>
-                          <a:ea typeface="AppleGothic"/>
-                        </a:rPr>
-                        <a:t>decay+transport</a:t>
-                      </a:r>
-                    </a:p>
-                  </a:txBody>
-                  <a:tcPr anchor="ctr">
-                    <a:solidFill>
-                      <a:srgbClr val="F5F5F5"/>
-                    </a:solidFill>
-                  </a:tcPr>
-                </a:tc>
-                <a:tc>
-                  <a:txBody>
-                    <a:bodyPr/>
-                    <a:lstStyle/>
-                    <a:p>
-                      <a:pPr algn="ctr"/>
-                      <a:r>
-                        <a:rPr sz="1000" b="0">
-                          <a:solidFill>
-                            <a:srgbClr val="222222"/>
-                          </a:solidFill>
-                          <a:latin typeface="Arial"/>
-                          <a:ea typeface="AppleGothic"/>
-                        </a:rPr>
-                        <a:t>0.862</a:t>
-                      </a:r>
-                    </a:p>
-                  </a:txBody>
-                  <a:tcPr anchor="ctr">
-                    <a:solidFill>
-                      <a:srgbClr val="F5F5F5"/>
-                    </a:solidFill>
-                  </a:tcPr>
-                </a:tc>
-              </a:tr>
-              <a:tr h="365760">
-                <a:tc>
-                  <a:txBody>
-                    <a:bodyPr/>
-                    <a:lstStyle/>
-                    <a:p>
-                      <a:pPr algn="l"/>
-                      <a:r>
-                        <a:rPr sz="1000" b="1">
-                          <a:solidFill>
-                            <a:srgbClr val="222222"/>
-                          </a:solidFill>
-                          <a:latin typeface="Arial"/>
-                          <a:ea typeface="AppleGothic"/>
-                        </a:rPr>
-                        <a:t>미시간 배터리</a:t>
-                      </a:r>
-                    </a:p>
-                  </a:txBody>
-                  <a:tcPr anchor="ctr">
-                    <a:solidFill>
-                      <a:srgbClr val="FFFFFF"/>
-                    </a:solidFill>
-                  </a:tcPr>
-                </a:tc>
-                <a:tc>
-                  <a:txBody>
-                    <a:bodyPr/>
-                    <a:lstStyle/>
-                    <a:p>
-                      <a:pPr algn="ctr"/>
-                      <a:r>
-                        <a:rPr sz="1000" b="0">
-                          <a:solidFill>
-                            <a:srgbClr val="222222"/>
-                          </a:solidFill>
-                          <a:latin typeface="Arial"/>
-                          <a:ea typeface="AppleGothic"/>
-                        </a:rPr>
-                        <a:t>dual-scale</a:t>
-                      </a:r>
-                    </a:p>
-                  </a:txBody>
-                  <a:tcPr anchor="ctr">
-                    <a:solidFill>
-                      <a:srgbClr val="FFFFFF"/>
-                    </a:solidFill>
-                  </a:tcPr>
-                </a:tc>
-                <a:tc>
-                  <a:txBody>
-                    <a:bodyPr/>
-                    <a:lstStyle/>
-                    <a:p>
-                      <a:pPr algn="ctr"/>
-                      <a:r>
-                        <a:rPr sz="1000" b="0">
-                          <a:solidFill>
-                            <a:srgbClr val="222222"/>
-                          </a:solidFill>
-                          <a:latin typeface="Arial"/>
-                          <a:ea typeface="AppleGothic"/>
-                        </a:rPr>
-                        <a:t>0.751</a:t>
-                      </a:r>
-                    </a:p>
-                  </a:txBody>
-                  <a:tcPr anchor="ctr">
-                    <a:solidFill>
-                      <a:srgbClr val="FFFFFF"/>
-                    </a:solidFill>
-                  </a:tcPr>
-                </a:tc>
-              </a:tr>
-              <a:tr h="365760">
-                <a:tc>
-                  <a:txBody>
-                    <a:bodyPr/>
-                    <a:lstStyle/>
-                    <a:p>
-                      <a:pPr algn="l"/>
-                      <a:r>
-                        <a:rPr sz="1000" b="1">
-                          <a:solidFill>
-                            <a:srgbClr val="222222"/>
-                          </a:solidFill>
-                          <a:latin typeface="Arial"/>
-                          <a:ea typeface="AppleGothic"/>
-                        </a:rPr>
-                        <a:t>NASA 실험셀</a:t>
-                      </a:r>
-                    </a:p>
-                  </a:txBody>
-                  <a:tcPr anchor="ctr">
-                    <a:solidFill>
-                      <a:srgbClr val="F5F5F5"/>
-                    </a:solidFill>
-                  </a:tcPr>
-                </a:tc>
-                <a:tc>
-                  <a:txBody>
-                    <a:bodyPr/>
-                    <a:lstStyle/>
-                    <a:p>
-                      <a:pPr algn="ctr"/>
-                      <a:r>
-                        <a:rPr sz="1000" b="0">
-                          <a:solidFill>
-                            <a:srgbClr val="222222"/>
-                          </a:solidFill>
-                          <a:latin typeface="Arial"/>
-                          <a:ea typeface="AppleGothic"/>
-                        </a:rPr>
-                        <a:t>multiscale</a:t>
-                      </a:r>
-                    </a:p>
-                  </a:txBody>
-                  <a:tcPr anchor="ctr">
-                    <a:solidFill>
-                      <a:srgbClr val="F5F5F5"/>
-                    </a:solidFill>
-                  </a:tcPr>
-                </a:tc>
-                <a:tc>
-                  <a:txBody>
-                    <a:bodyPr/>
-                    <a:lstStyle/>
-                    <a:p>
-                      <a:pPr algn="ctr"/>
-                      <a:r>
-                        <a:rPr sz="1000" b="0">
-                          <a:solidFill>
-                            <a:srgbClr val="222222"/>
-                          </a:solidFill>
-                          <a:latin typeface="Arial"/>
-                          <a:ea typeface="AppleGothic"/>
-                        </a:rPr>
-                        <a:t>0.584</a:t>
-                      </a:r>
-                    </a:p>
-                  </a:txBody>
-                  <a:tcPr anchor="ctr">
-                    <a:solidFill>
-                      <a:srgbClr val="F5F5F5"/>
-                    </a:solidFill>
-                  </a:tcPr>
-                </a:tc>
-              </a:tr>
-              <a:tr h="365760">
-                <a:tc>
-                  <a:txBody>
-                    <a:bodyPr/>
-                    <a:lstStyle/>
-                    <a:p>
-                      <a:pPr algn="l"/>
-                      <a:r>
-                        <a:rPr sz="1000" b="1">
-                          <a:solidFill>
-                            <a:srgbClr val="222222"/>
-                          </a:solidFill>
-                          <a:latin typeface="Arial"/>
-                          <a:ea typeface="AppleGothic"/>
-                        </a:rPr>
-                        <a:t>MIT 2019</a:t>
-                      </a:r>
-                    </a:p>
-                  </a:txBody>
-                  <a:tcPr anchor="ctr">
-                    <a:solidFill>
-                      <a:srgbClr val="FFFFFF"/>
-                    </a:solidFill>
-                  </a:tcPr>
-                </a:tc>
-                <a:tc>
-                  <a:txBody>
-                    <a:bodyPr/>
-                    <a:lstStyle/>
-                    <a:p>
-                      <a:pPr algn="ctr"/>
-                      <a:r>
-                        <a:rPr sz="1000" b="0">
-                          <a:solidFill>
-                            <a:srgbClr val="222222"/>
-                          </a:solidFill>
-                          <a:latin typeface="Arial"/>
-                          <a:ea typeface="AppleGothic"/>
-                        </a:rPr>
-                        <a:t>affine latent-regime + Val calibration</a:t>
-                      </a:r>
-                    </a:p>
-                  </a:txBody>
-                  <a:tcPr anchor="ctr">
-                    <a:solidFill>
-                      <a:srgbClr val="FFFFFF"/>
-                    </a:solidFill>
-                  </a:tcPr>
-                </a:tc>
-                <a:tc>
-                  <a:txBody>
-                    <a:bodyPr/>
-                    <a:lstStyle/>
-                    <a:p>
-                      <a:pPr algn="ctr"/>
-                      <a:r>
-                        <a:rPr sz="1000" b="0">
-                          <a:solidFill>
-                            <a:srgbClr val="222222"/>
-                          </a:solidFill>
-                          <a:latin typeface="Arial"/>
-                          <a:ea typeface="AppleGothic"/>
-                        </a:rPr>
-                        <a:t>0.466</a:t>
-                      </a:r>
-                    </a:p>
-                  </a:txBody>
-                  <a:tcPr anchor="ctr">
-                    <a:solidFill>
-                      <a:srgbClr val="FFFFFF"/>
-                    </a:solidFill>
-                  </a:tcPr>
-                </a:tc>
-              </a:tr>
-            </a:tbl>
-          </a:graphicData>
-        </a:graphic>
-      </p:graphicFrame>
-      <p:sp>
-        <p:nvSpPr>
-          <p:cNvPr id="8" name="Rounded Rectangle 7"/>
-          <p:cNvSpPr/>
-          <p:nvPr/>
-        </p:nvSpPr>
-        <p:spPr>
-          <a:xfrm>
-            <a:off x="342900" y="4648200"/>
-            <a:ext cx="3810000" cy="1600200"/>
-          </a:xfrm>
-          <a:prstGeom prst="roundRect">
-            <a:avLst>
-              <a:gd name="adj" fmla="val 12000"/>
-            </a:avLst>
-          </a:prstGeom>
-          <a:solidFill>
-            <a:srgbClr val="E8F1F8"/>
-          </a:solidFill>
-          <a:ln w="15875">
-            <a:solidFill>
-              <a:srgbClr val="0072B2"/>
-            </a:solidFill>
-          </a:ln>
-        </p:spPr>
-        <p:style>
-          <a:lnRef idx="1">
-            <a:schemeClr val="accent1"/>
-          </a:lnRef>
-          <a:fillRef idx="3">
-            <a:schemeClr val="accent1"/>
-          </a:fillRef>
-          <a:effectRef idx="2">
-            <a:schemeClr val="accent1"/>
-          </a:effectRef>
-          <a:fontRef idx="minor">
-            <a:schemeClr val="lt1"/>
-          </a:fontRef>
-        </p:style>
-        <p:txBody>
-          <a:bodyPr rtlCol="0" anchor="ctr"/>
-          <a:lstStyle/>
-          <a:p>
-            <a:pPr algn="ctr"/>
-          </a:p>
-        </p:txBody>
-      </p:sp>
-      <p:sp>
-        <p:nvSpPr>
-          <p:cNvPr id="9" name="Rectangle 8"/>
-          <p:cNvSpPr/>
-          <p:nvPr/>
-        </p:nvSpPr>
-        <p:spPr>
-          <a:xfrm>
-            <a:off x="342900" y="4648200"/>
-            <a:ext cx="76200" cy="1600200"/>
-          </a:xfrm>
-          <a:prstGeom prst="rect">
-            <a:avLst/>
-          </a:prstGeom>
-          <a:solidFill>
-            <a:srgbClr val="0072B2"/>
-          </a:solidFill>
-          <a:ln>
-            <a:noFill/>
-          </a:ln>
-        </p:spPr>
-        <p:style>
-          <a:lnRef idx="1">
-            <a:schemeClr val="accent1"/>
-          </a:lnRef>
-          <a:fillRef idx="3">
-            <a:schemeClr val="accent1"/>
-          </a:fillRef>
-          <a:effectRef idx="2">
-            <a:schemeClr val="accent1"/>
-          </a:effectRef>
-          <a:fontRef idx="minor">
-            <a:schemeClr val="lt1"/>
-          </a:fontRef>
-        </p:style>
-        <p:txBody>
-          <a:bodyPr rtlCol="0" anchor="ctr"/>
-          <a:lstStyle/>
-          <a:p>
-            <a:pPr algn="ctr"/>
-          </a:p>
-        </p:txBody>
-      </p:sp>
-      <p:sp>
-        <p:nvSpPr>
-          <p:cNvPr id="10" name="TextBox 9"/>
-          <p:cNvSpPr txBox="1"/>
-          <p:nvPr/>
-        </p:nvSpPr>
-        <p:spPr>
-          <a:xfrm>
-            <a:off x="533400" y="4743450"/>
-            <a:ext cx="3429000" cy="209550"/>
-          </a:xfrm>
-          <a:prstGeom prst="rect">
-            <a:avLst/>
-          </a:prstGeom>
-          <a:noFill/>
-        </p:spPr>
-        <p:txBody>
-          <a:bodyPr wrap="square">
-            <a:spAutoFit/>
-          </a:bodyPr>
-          <a:lstStyle/>
-          <a:p>
-            <a:pPr algn="l"/>
-            <a:r>
-              <a:rPr sz="1300" b="1">
-                <a:solidFill>
-                  <a:srgbClr val="0072B2"/>
-                </a:solidFill>
-                <a:latin typeface="Arial"/>
-                <a:ea typeface="AppleGothic"/>
-              </a:rPr>
-              <a:t>Li 배터리</a:t>
-            </a:r>
-          </a:p>
-        </p:txBody>
-      </p:sp>
-      <p:sp>
-        <p:nvSpPr>
-          <p:cNvPr id="11" name="TextBox 10"/>
-          <p:cNvSpPr txBox="1"/>
-          <p:nvPr/>
-        </p:nvSpPr>
-        <p:spPr>
-          <a:xfrm>
-            <a:off x="533400" y="4991100"/>
-            <a:ext cx="3429000" cy="1143000"/>
-          </a:xfrm>
-          <a:prstGeom prst="rect">
-            <a:avLst/>
-          </a:prstGeom>
-          <a:noFill/>
-        </p:spPr>
-        <p:txBody>
-          <a:bodyPr wrap="square">
-            <a:spAutoFit/>
-          </a:bodyPr>
-          <a:lstStyle/>
-          <a:p>
-            <a:pPr algn="l"/>
-            <a:r>
-              <a:rPr sz="1100" b="0">
-                <a:solidFill>
-                  <a:srgbClr val="222222"/>
-                </a:solidFill>
-                <a:latin typeface="Arial"/>
-                <a:ea typeface="AppleGothic"/>
-              </a:rPr>
-              <a:t>화중·선우다·아헨·미시간 리튬셀</a:t>
-            </a:r>
-          </a:p>
-          <a:p>
-            <a:pPr algn="l"/>
-            <a:r>
-              <a:rPr sz="1100" b="0">
-                <a:solidFill>
-                  <a:srgbClr val="222222"/>
-                </a:solidFill>
-                <a:latin typeface="Arial"/>
-                <a:ea typeface="AppleGothic"/>
-              </a:rPr>
-              <a:t>MIT 수명 벤치 (2019 / 배치2)</a:t>
-            </a:r>
-          </a:p>
-          <a:p>
-            <a:pPr algn="l"/>
-            <a:r>
-              <a:rPr sz="1100" b="0">
-                <a:solidFill>
-                  <a:srgbClr val="222222"/>
-                </a:solidFill>
-                <a:latin typeface="Arial"/>
-                <a:ea typeface="AppleGothic"/>
-              </a:rPr>
-              <a:t>NASA 실험용 18650  (로켓 아님)</a:t>
-            </a:r>
-          </a:p>
-        </p:txBody>
-      </p:sp>
-      <p:sp>
-        <p:nvSpPr>
-          <p:cNvPr id="12" name="Rounded Rectangle 11"/>
-          <p:cNvSpPr/>
-          <p:nvPr/>
-        </p:nvSpPr>
-        <p:spPr>
-          <a:xfrm>
-            <a:off x="4305300" y="4648200"/>
-            <a:ext cx="3619500" cy="1600200"/>
-          </a:xfrm>
-          <a:prstGeom prst="roundRect">
-            <a:avLst>
-              <a:gd name="adj" fmla="val 12000"/>
-            </a:avLst>
-          </a:prstGeom>
-          <a:solidFill>
-            <a:srgbClr val="F5F5F5"/>
-          </a:solidFill>
-          <a:ln w="15875">
-            <a:solidFill>
-              <a:srgbClr val="222222"/>
-            </a:solidFill>
-          </a:ln>
-        </p:spPr>
-        <p:style>
-          <a:lnRef idx="1">
-            <a:schemeClr val="accent1"/>
-          </a:lnRef>
-          <a:fillRef idx="3">
-            <a:schemeClr val="accent1"/>
-          </a:fillRef>
-          <a:effectRef idx="2">
-            <a:schemeClr val="accent1"/>
-          </a:effectRef>
-          <a:fontRef idx="minor">
-            <a:schemeClr val="lt1"/>
-          </a:fontRef>
-        </p:style>
-        <p:txBody>
-          <a:bodyPr rtlCol="0" anchor="ctr"/>
-          <a:lstStyle/>
-          <a:p>
-            <a:pPr algn="ctr"/>
-          </a:p>
-        </p:txBody>
-      </p:sp>
-      <p:sp>
-        <p:nvSpPr>
-          <p:cNvPr id="13" name="Rectangle 12"/>
-          <p:cNvSpPr/>
-          <p:nvPr/>
-        </p:nvSpPr>
-        <p:spPr>
-          <a:xfrm>
-            <a:off x="4305300" y="4648200"/>
-            <a:ext cx="76200" cy="1600200"/>
-          </a:xfrm>
-          <a:prstGeom prst="rect">
-            <a:avLst/>
-          </a:prstGeom>
-          <a:solidFill>
-            <a:srgbClr val="222222"/>
-          </a:solidFill>
-          <a:ln>
-            <a:noFill/>
-          </a:ln>
-        </p:spPr>
-        <p:style>
-          <a:lnRef idx="1">
-            <a:schemeClr val="accent1"/>
-          </a:lnRef>
-          <a:fillRef idx="3">
-            <a:schemeClr val="accent1"/>
-          </a:fillRef>
-          <a:effectRef idx="2">
-            <a:schemeClr val="accent1"/>
-          </a:effectRef>
-          <a:fontRef idx="minor">
-            <a:schemeClr val="lt1"/>
-          </a:fontRef>
-        </p:style>
-        <p:txBody>
-          <a:bodyPr rtlCol="0" anchor="ctr"/>
-          <a:lstStyle/>
-          <a:p>
-            <a:pPr algn="ctr"/>
-          </a:p>
-        </p:txBody>
-      </p:sp>
-      <p:sp>
-        <p:nvSpPr>
-          <p:cNvPr id="14" name="TextBox 13"/>
-          <p:cNvSpPr txBox="1"/>
-          <p:nvPr/>
-        </p:nvSpPr>
-        <p:spPr>
-          <a:xfrm>
-            <a:off x="4495800" y="4743450"/>
-            <a:ext cx="3238500" cy="209550"/>
-          </a:xfrm>
-          <a:prstGeom prst="rect">
-            <a:avLst/>
-          </a:prstGeom>
-          <a:noFill/>
-        </p:spPr>
-        <p:txBody>
-          <a:bodyPr wrap="square">
-            <a:spAutoFit/>
-          </a:bodyPr>
-          <a:lstStyle/>
-          <a:p>
-            <a:pPr algn="l"/>
-            <a:r>
-              <a:rPr sz="1300" b="1">
-                <a:solidFill>
-                  <a:srgbClr val="222222"/>
-                </a:solidFill>
-                <a:latin typeface="Arial"/>
-                <a:ea typeface="AppleGothic"/>
-              </a:rPr>
-              <a:t>균열</a:t>
-            </a:r>
-          </a:p>
-        </p:txBody>
-      </p:sp>
-      <p:sp>
-        <p:nvSpPr>
-          <p:cNvPr id="15" name="TextBox 14"/>
-          <p:cNvSpPr txBox="1"/>
-          <p:nvPr/>
-        </p:nvSpPr>
-        <p:spPr>
-          <a:xfrm>
-            <a:off x="4495800" y="4991100"/>
-            <a:ext cx="3238500" cy="1047750"/>
-          </a:xfrm>
-          <a:prstGeom prst="rect">
-            <a:avLst/>
-          </a:prstGeom>
-          <a:noFill/>
-        </p:spPr>
-        <p:txBody>
-          <a:bodyPr wrap="square">
-            <a:spAutoFit/>
-          </a:bodyPr>
-          <a:lstStyle/>
-          <a:p>
-            <a:pPr algn="l"/>
-            <a:r>
-              <a:rPr sz="1200" b="0">
-                <a:solidFill>
-                  <a:srgbClr val="222222"/>
-                </a:solidFill>
-                <a:latin typeface="Arial"/>
-                <a:ea typeface="AppleGothic"/>
-              </a:rPr>
-              <a:t>알루미늄 판에 금이 감</a:t>
-            </a:r>
-          </a:p>
-          <a:p>
-            <a:pPr algn="l"/>
-            <a:r>
-              <a:rPr sz="1200" b="0">
-                <a:solidFill>
-                  <a:srgbClr val="222222"/>
-                </a:solidFill>
-                <a:latin typeface="Arial"/>
-                <a:ea typeface="AppleGothic"/>
-              </a:rPr>
-              <a:t>항공기 재료 피로실험</a:t>
-            </a:r>
-          </a:p>
-          <a:p>
-            <a:pPr algn="l"/>
-            <a:r>
-              <a:rPr sz="1200" b="0">
-                <a:solidFill>
-                  <a:srgbClr val="222222"/>
-                </a:solidFill>
-                <a:latin typeface="Arial"/>
-                <a:ea typeface="AppleGothic"/>
-              </a:rPr>
-              <a:t>배터리 아님</a:t>
-            </a:r>
-          </a:p>
-        </p:txBody>
-      </p:sp>
-      <p:sp>
-        <p:nvSpPr>
-          <p:cNvPr id="16" name="Rounded Rectangle 15"/>
-          <p:cNvSpPr/>
-          <p:nvPr/>
-        </p:nvSpPr>
-        <p:spPr>
-          <a:xfrm>
-            <a:off x="8077200" y="4648200"/>
-            <a:ext cx="3771900" cy="1600200"/>
-          </a:xfrm>
-          <a:prstGeom prst="roundRect">
-            <a:avLst>
-              <a:gd name="adj" fmla="val 12000"/>
-            </a:avLst>
-          </a:prstGeom>
-          <a:solidFill>
-            <a:srgbClr val="FDF4E3"/>
-          </a:solidFill>
-          <a:ln w="15875">
-            <a:solidFill>
-              <a:srgbClr val="E69F00"/>
-            </a:solidFill>
-          </a:ln>
-        </p:spPr>
-        <p:style>
-          <a:lnRef idx="1">
-            <a:schemeClr val="accent1"/>
-          </a:lnRef>
-          <a:fillRef idx="3">
-            <a:schemeClr val="accent1"/>
-          </a:fillRef>
-          <a:effectRef idx="2">
-            <a:schemeClr val="accent1"/>
-          </a:effectRef>
-          <a:fontRef idx="minor">
-            <a:schemeClr val="lt1"/>
-          </a:fontRef>
-        </p:style>
-        <p:txBody>
-          <a:bodyPr rtlCol="0" anchor="ctr"/>
-          <a:lstStyle/>
-          <a:p>
-            <a:pPr algn="ctr"/>
-          </a:p>
-        </p:txBody>
-      </p:sp>
-      <p:sp>
-        <p:nvSpPr>
-          <p:cNvPr id="17" name="Rectangle 16"/>
-          <p:cNvSpPr/>
-          <p:nvPr/>
-        </p:nvSpPr>
-        <p:spPr>
-          <a:xfrm>
-            <a:off x="8077200" y="4648200"/>
-            <a:ext cx="76200" cy="1600200"/>
-          </a:xfrm>
-          <a:prstGeom prst="rect">
-            <a:avLst/>
-          </a:prstGeom>
-          <a:solidFill>
-            <a:srgbClr val="E69F00"/>
-          </a:solidFill>
-          <a:ln>
-            <a:noFill/>
-          </a:ln>
-        </p:spPr>
-        <p:style>
-          <a:lnRef idx="1">
-            <a:schemeClr val="accent1"/>
-          </a:lnRef>
-          <a:fillRef idx="3">
-            <a:schemeClr val="accent1"/>
-          </a:fillRef>
-          <a:effectRef idx="2">
-            <a:schemeClr val="accent1"/>
-          </a:effectRef>
-          <a:fontRef idx="minor">
-            <a:schemeClr val="lt1"/>
-          </a:fontRef>
-        </p:style>
-        <p:txBody>
-          <a:bodyPr rtlCol="0" anchor="ctr"/>
-          <a:lstStyle/>
-          <a:p>
-            <a:pPr algn="ctr"/>
-          </a:p>
-        </p:txBody>
-      </p:sp>
-      <p:sp>
-        <p:nvSpPr>
-          <p:cNvPr id="18" name="TextBox 17"/>
-          <p:cNvSpPr txBox="1"/>
-          <p:nvPr/>
-        </p:nvSpPr>
-        <p:spPr>
-          <a:xfrm>
-            <a:off x="8267700" y="4743450"/>
-            <a:ext cx="3390900" cy="209550"/>
-          </a:xfrm>
-          <a:prstGeom prst="rect">
-            <a:avLst/>
-          </a:prstGeom>
-          <a:noFill/>
-        </p:spPr>
-        <p:txBody>
-          <a:bodyPr wrap="square">
-            <a:spAutoFit/>
-          </a:bodyPr>
-          <a:lstStyle/>
-          <a:p>
-            <a:pPr algn="l"/>
-            <a:r>
-              <a:rPr sz="1300" b="1">
-                <a:solidFill>
-                  <a:srgbClr val="E69F00"/>
-                </a:solidFill>
-                <a:latin typeface="Arial"/>
-                <a:ea typeface="AppleGothic"/>
-              </a:rPr>
-              <a:t>엔진</a:t>
-            </a:r>
-          </a:p>
-        </p:txBody>
-      </p:sp>
-      <p:sp>
-        <p:nvSpPr>
-          <p:cNvPr id="19" name="TextBox 18"/>
-          <p:cNvSpPr txBox="1"/>
-          <p:nvPr/>
-        </p:nvSpPr>
-        <p:spPr>
-          <a:xfrm>
-            <a:off x="8267700" y="4991100"/>
-            <a:ext cx="3390900" cy="1047750"/>
-          </a:xfrm>
-          <a:prstGeom prst="rect">
-            <a:avLst/>
-          </a:prstGeom>
-          <a:noFill/>
-        </p:spPr>
-        <p:txBody>
-          <a:bodyPr wrap="square">
-            <a:spAutoFit/>
-          </a:bodyPr>
-          <a:lstStyle/>
-          <a:p>
-            <a:pPr algn="l"/>
-            <a:r>
-              <a:rPr sz="1200" b="0">
-                <a:solidFill>
-                  <a:srgbClr val="222222"/>
-                </a:solidFill>
-                <a:latin typeface="Arial"/>
-                <a:ea typeface="AppleGothic"/>
-              </a:rPr>
-              <a:t>항공기 엔진 시뮬레이터</a:t>
-            </a:r>
-          </a:p>
-          <a:p>
-            <a:pPr algn="l"/>
-            <a:r>
-              <a:rPr sz="1200" b="0">
-                <a:solidFill>
-                  <a:srgbClr val="222222"/>
-                </a:solidFill>
-                <a:latin typeface="Arial"/>
-                <a:ea typeface="AppleGothic"/>
-              </a:rPr>
-              <a:t>처음 보는 비행조건</a:t>
-            </a:r>
-          </a:p>
-          <a:p>
-            <a:pPr algn="l"/>
-            <a:r>
-              <a:rPr sz="1200" b="0">
-                <a:solidFill>
-                  <a:srgbClr val="222222"/>
-                </a:solidFill>
-                <a:latin typeface="Arial"/>
-                <a:ea typeface="AppleGothic"/>
-              </a:rPr>
-              <a:t>실제 비행기 데이터가 아님</a:t>
-            </a:r>
-          </a:p>
-        </p:txBody>
-      </p:sp>
-      <p:cxnSp>
-        <p:nvCxnSpPr>
-          <p:cNvPr id="20" name="Connector 19"/>
-          <p:cNvCxnSpPr/>
-          <p:nvPr/>
-        </p:nvCxnSpPr>
-        <p:spPr>
-          <a:xfrm>
-            <a:off x="457200" y="6477000"/>
-            <a:ext cx="11277600" cy="0"/>
-          </a:xfrm>
-          <a:prstGeom prst="line">
-            <a:avLst/>
-          </a:prstGeom>
-          <a:ln w="9525">
-            <a:solidFill>
-              <a:srgbClr val="E8E8E8"/>
-            </a:solidFill>
-          </a:ln>
-        </p:spPr>
-        <p:style>
-          <a:lnRef idx="2">
-            <a:schemeClr val="accent1"/>
-          </a:lnRef>
-          <a:fillRef idx="0">
-            <a:schemeClr val="accent1"/>
-          </a:fillRef>
-          <a:effectRef idx="1">
-            <a:schemeClr val="accent1"/>
-          </a:effectRef>
-          <a:fontRef idx="minor">
-            <a:schemeClr val="tx1"/>
-          </a:fontRef>
-        </p:style>
-      </p:cxnSp>
-      <p:sp>
-        <p:nvSpPr>
-          <p:cNvPr id="21" name="TextBox 20"/>
-          <p:cNvSpPr txBox="1"/>
-          <p:nvPr/>
-        </p:nvSpPr>
-        <p:spPr>
-          <a:xfrm>
-            <a:off x="457200" y="6534150"/>
-            <a:ext cx="7620000" cy="133350"/>
-          </a:xfrm>
-          <a:prstGeom prst="rect">
-            <a:avLst/>
-          </a:prstGeom>
-          <a:noFill/>
-        </p:spPr>
-        <p:txBody>
-          <a:bodyPr wrap="square">
-            <a:spAutoFit/>
-          </a:bodyPr>
-          <a:lstStyle/>
-          <a:p>
-            <a:pPr algn="l"/>
-            <a:r>
-              <a:rPr sz="900" b="0">
-                <a:solidFill>
-                  <a:srgbClr val="666666"/>
-                </a:solidFill>
-                <a:latin typeface="Arial"/>
-                <a:ea typeface="AppleGothic"/>
-              </a:rPr>
-              <a:t>SPS Lab  ·  Prior-Adaptive Extrapolation  ·  PP-X</a:t>
-            </a:r>
-          </a:p>
-        </p:txBody>
-      </p:sp>
-      <p:sp>
-        <p:nvSpPr>
-          <p:cNvPr id="22" name="TextBox 21"/>
-          <p:cNvSpPr txBox="1"/>
-          <p:nvPr/>
-        </p:nvSpPr>
-        <p:spPr>
-          <a:xfrm>
-            <a:off x="10477500" y="6515100"/>
-            <a:ext cx="952500" cy="152400"/>
-          </a:xfrm>
-          <a:prstGeom prst="rect">
-            <a:avLst/>
-          </a:prstGeom>
-          <a:noFill/>
-        </p:spPr>
-        <p:txBody>
-          <a:bodyPr wrap="square">
-            <a:spAutoFit/>
-          </a:bodyPr>
-          <a:lstStyle/>
-          <a:p>
-            <a:pPr algn="r"/>
-            <a:r>
-              <a:rPr sz="1000" b="1">
-                <a:solidFill>
-                  <a:srgbClr val="666666"/>
-                </a:solidFill>
-                <a:latin typeface="Arial"/>
-                <a:ea typeface="AppleGothic"/>
-              </a:rPr>
-              <a:t>14/42</a:t>
-            </a:r>
-          </a:p>
-        </p:txBody>
-      </p:sp>
-    </p:spTree>
-  </p:cSld>
-  <p:clrMapOvr>
-    <a:masterClrMapping/>
-  </p:clrMapOvr>
-</p:sld>
-</file>
-
 <file path=ppt/slides/slide14.xml><?xml version="1.0" encoding="utf-8"?>
 <p:sld xmlns:a="http://schemas.openxmlformats.org/drawingml/2006/main" xmlns:p="http://schemas.openxmlformats.org/presentationml/2006/main" xmlns:r="http://schemas.openxmlformats.org/officeDocument/2006/relationships">
   <p:cSld>
@@ -12986,385 +10216,6 @@
 </p:sld>
 </file>
 
-<file path=ppt/slides/slide15.xml><?xml version="1.0" encoding="utf-8"?>
-<p:sld xmlns:a="http://schemas.openxmlformats.org/drawingml/2006/main" xmlns:p="http://schemas.openxmlformats.org/presentationml/2006/main" xmlns:r="http://schemas.openxmlformats.org/officeDocument/2006/relationships">
-  <p:cSld>
-    <p:spTree>
-      <p:nvGrpSpPr>
-        <p:cNvPr id="1" name=""/>
-        <p:cNvGrpSpPr/>
-        <p:nvPr/>
-      </p:nvGrpSpPr>
-      <p:grpSpPr/>
-      <p:sp>
-        <p:nvSpPr>
-          <p:cNvPr id="2" name="Rectangle 1"/>
-          <p:cNvSpPr/>
-          <p:nvPr/>
-        </p:nvSpPr>
-        <p:spPr>
-          <a:xfrm>
-            <a:off x="0" y="0"/>
-            <a:ext cx="12192000" cy="6858000"/>
-          </a:xfrm>
-          <a:prstGeom prst="rect">
-            <a:avLst/>
-          </a:prstGeom>
-          <a:solidFill>
-            <a:srgbClr val="FFFFFF"/>
-          </a:solidFill>
-          <a:ln>
-            <a:noFill/>
-          </a:ln>
-        </p:spPr>
-        <p:style>
-          <a:lnRef idx="1">
-            <a:schemeClr val="accent1"/>
-          </a:lnRef>
-          <a:fillRef idx="3">
-            <a:schemeClr val="accent1"/>
-          </a:fillRef>
-          <a:effectRef idx="2">
-            <a:schemeClr val="accent1"/>
-          </a:effectRef>
-          <a:fontRef idx="minor">
-            <a:schemeClr val="lt1"/>
-          </a:fontRef>
-        </p:style>
-        <p:txBody>
-          <a:bodyPr rtlCol="0" anchor="ctr"/>
-          <a:lstStyle/>
-          <a:p>
-            <a:pPr algn="ctr"/>
-          </a:p>
-        </p:txBody>
-      </p:sp>
-      <p:sp>
-        <p:nvSpPr>
-          <p:cNvPr id="3" name="Rectangle 2"/>
-          <p:cNvSpPr/>
-          <p:nvPr/>
-        </p:nvSpPr>
-        <p:spPr>
-          <a:xfrm>
-            <a:off x="0" y="0"/>
-            <a:ext cx="12192000" cy="19050"/>
-          </a:xfrm>
-          <a:prstGeom prst="rect">
-            <a:avLst/>
-          </a:prstGeom>
-          <a:solidFill>
-            <a:srgbClr val="222222"/>
-          </a:solidFill>
-          <a:ln>
-            <a:noFill/>
-          </a:ln>
-        </p:spPr>
-        <p:style>
-          <a:lnRef idx="1">
-            <a:schemeClr val="accent1"/>
-          </a:lnRef>
-          <a:fillRef idx="3">
-            <a:schemeClr val="accent1"/>
-          </a:fillRef>
-          <a:effectRef idx="2">
-            <a:schemeClr val="accent1"/>
-          </a:effectRef>
-          <a:fontRef idx="minor">
-            <a:schemeClr val="lt1"/>
-          </a:fontRef>
-        </p:style>
-        <p:txBody>
-          <a:bodyPr rtlCol="0" anchor="ctr"/>
-          <a:lstStyle/>
-          <a:p>
-            <a:pPr algn="ctr"/>
-          </a:p>
-        </p:txBody>
-      </p:sp>
-      <p:sp>
-        <p:nvSpPr>
-          <p:cNvPr id="4" name="TextBox 3"/>
-          <p:cNvSpPr txBox="1"/>
-          <p:nvPr/>
-        </p:nvSpPr>
-        <p:spPr>
-          <a:xfrm>
-            <a:off x="457200" y="209550"/>
-            <a:ext cx="11239500" cy="304800"/>
-          </a:xfrm>
-          <a:prstGeom prst="rect">
-            <a:avLst/>
-          </a:prstGeom>
-          <a:noFill/>
-        </p:spPr>
-        <p:txBody>
-          <a:bodyPr wrap="square">
-            <a:spAutoFit/>
-          </a:bodyPr>
-          <a:lstStyle/>
-          <a:p>
-            <a:pPr algn="l"/>
-            <a:r>
-              <a:rPr sz="2200" b="1">
-                <a:solidFill>
-                  <a:srgbClr val="222222"/>
-                </a:solidFill>
-                <a:latin typeface="Arial"/>
-                <a:ea typeface="AppleGothic"/>
-              </a:rPr>
-              <a:t>Ablation — dual-scale</a:t>
-            </a:r>
-          </a:p>
-        </p:txBody>
-      </p:sp>
-      <p:sp>
-        <p:nvSpPr>
-          <p:cNvPr id="5" name="TextBox 4"/>
-          <p:cNvSpPr txBox="1"/>
-          <p:nvPr/>
-        </p:nvSpPr>
-        <p:spPr>
-          <a:xfrm>
-            <a:off x="457200" y="514350"/>
-            <a:ext cx="11239500" cy="190500"/>
-          </a:xfrm>
-          <a:prstGeom prst="rect">
-            <a:avLst/>
-          </a:prstGeom>
-          <a:noFill/>
-        </p:spPr>
-        <p:txBody>
-          <a:bodyPr wrap="square">
-            <a:spAutoFit/>
-          </a:bodyPr>
-          <a:lstStyle/>
-          <a:p>
-            <a:pPr algn="l"/>
-            <a:r>
-              <a:rPr sz="1200" b="0">
-                <a:solidFill>
-                  <a:srgbClr val="666666"/>
-                </a:solidFill>
-                <a:latin typeface="Arial"/>
-                <a:ea typeface="AppleGothic"/>
-              </a:rPr>
-              <a:t>executor 하나  ·  모든 데이터에 켜는 기본값이 아니다</a:t>
-            </a:r>
-          </a:p>
-        </p:txBody>
-      </p:sp>
-      <p:pic>
-        <p:nvPicPr>
-          <p:cNvPr id="6" name="Picture 5" descr="ablation_panel.png"/>
-          <p:cNvPicPr>
-            <a:picLocks noChangeAspect="1"/>
-          </p:cNvPicPr>
-          <p:nvPr/>
-        </p:nvPicPr>
-        <p:blipFill>
-          <a:blip r:embed="rId2"/>
-          <a:stretch>
-            <a:fillRect/>
-          </a:stretch>
-        </p:blipFill>
-        <p:spPr>
-          <a:xfrm>
-            <a:off x="228600" y="781050"/>
-            <a:ext cx="11734800" cy="4095750"/>
-          </a:xfrm>
-          <a:prstGeom prst="rect">
-            <a:avLst/>
-          </a:prstGeom>
-        </p:spPr>
-      </p:pic>
-      <p:sp>
-        <p:nvSpPr>
-          <p:cNvPr id="7" name="TextBox 6"/>
-          <p:cNvSpPr txBox="1"/>
-          <p:nvPr/>
-        </p:nvSpPr>
-        <p:spPr>
-          <a:xfrm>
-            <a:off x="457200" y="4953000"/>
-            <a:ext cx="5524500" cy="857250"/>
-          </a:xfrm>
-          <a:prstGeom prst="rect">
-            <a:avLst/>
-          </a:prstGeom>
-          <a:noFill/>
-        </p:spPr>
-        <p:txBody>
-          <a:bodyPr wrap="square">
-            <a:spAutoFit/>
-          </a:bodyPr>
-          <a:lstStyle/>
-          <a:p>
-            <a:pPr algn="l"/>
-            <a:r>
-              <a:rPr sz="1300" b="0">
-                <a:solidFill>
-                  <a:srgbClr val="222222"/>
-                </a:solidFill>
-                <a:latin typeface="Arial"/>
-                <a:ea typeface="AppleGothic"/>
-              </a:rPr>
-              <a:t>(a) 결론  고정 bound는 Sun·RWTH에서는 높지만 MICH를 0.468에 묶는다. dual-scale을 켠 뒤에야 MICH가 0.751이 된다.</a:t>
-            </a:r>
-          </a:p>
-        </p:txBody>
-      </p:sp>
-      <p:sp>
-        <p:nvSpPr>
-          <p:cNvPr id="8" name="TextBox 7"/>
-          <p:cNvSpPr txBox="1"/>
-          <p:nvPr/>
-        </p:nvSpPr>
-        <p:spPr>
-          <a:xfrm>
-            <a:off x="6286500" y="4953000"/>
-            <a:ext cx="5448300" cy="857250"/>
-          </a:xfrm>
-          <a:prstGeom prst="rect">
-            <a:avLst/>
-          </a:prstGeom>
-          <a:noFill/>
-        </p:spPr>
-        <p:txBody>
-          <a:bodyPr wrap="square">
-            <a:spAutoFit/>
-          </a:bodyPr>
-          <a:lstStyle/>
-          <a:p>
-            <a:pPr algn="l"/>
-            <a:r>
-              <a:rPr sz="1300" b="0">
-                <a:solidFill>
-                  <a:srgbClr val="222222"/>
-                </a:solidFill>
-                <a:latin typeface="Arial"/>
-                <a:ea typeface="AppleGothic"/>
-              </a:rPr>
-              <a:t>(b) 결론  평균을 조금 낮추고 최저 점수를 올린 선택이다. 데이터별 최고점을 모은 모델이 아니다.</a:t>
-            </a:r>
-          </a:p>
-        </p:txBody>
-      </p:sp>
-      <p:cxnSp>
-        <p:nvCxnSpPr>
-          <p:cNvPr id="9" name="Connector 8"/>
-          <p:cNvCxnSpPr/>
-          <p:nvPr/>
-        </p:nvCxnSpPr>
-        <p:spPr>
-          <a:xfrm>
-            <a:off x="457200" y="6477000"/>
-            <a:ext cx="11277600" cy="0"/>
-          </a:xfrm>
-          <a:prstGeom prst="line">
-            <a:avLst/>
-          </a:prstGeom>
-          <a:ln w="9525">
-            <a:solidFill>
-              <a:srgbClr val="E8E8E8"/>
-            </a:solidFill>
-          </a:ln>
-        </p:spPr>
-        <p:style>
-          <a:lnRef idx="2">
-            <a:schemeClr val="accent1"/>
-          </a:lnRef>
-          <a:fillRef idx="0">
-            <a:schemeClr val="accent1"/>
-          </a:fillRef>
-          <a:effectRef idx="1">
-            <a:schemeClr val="accent1"/>
-          </a:effectRef>
-          <a:fontRef idx="minor">
-            <a:schemeClr val="tx1"/>
-          </a:fontRef>
-        </p:style>
-      </p:cxnSp>
-      <p:sp>
-        <p:nvSpPr>
-          <p:cNvPr id="10" name="TextBox 9"/>
-          <p:cNvSpPr txBox="1"/>
-          <p:nvPr/>
-        </p:nvSpPr>
-        <p:spPr>
-          <a:xfrm>
-            <a:off x="457200" y="6534150"/>
-            <a:ext cx="7620000" cy="133350"/>
-          </a:xfrm>
-          <a:prstGeom prst="rect">
-            <a:avLst/>
-          </a:prstGeom>
-          <a:noFill/>
-        </p:spPr>
-        <p:txBody>
-          <a:bodyPr wrap="square">
-            <a:spAutoFit/>
-          </a:bodyPr>
-          <a:lstStyle/>
-          <a:p>
-            <a:pPr algn="l"/>
-            <a:r>
-              <a:rPr sz="900" b="0">
-                <a:solidFill>
-                  <a:srgbClr val="666666"/>
-                </a:solidFill>
-                <a:latin typeface="Arial"/>
-                <a:ea typeface="AppleGothic"/>
-              </a:rPr>
-              <a:t>SPS Lab  ·  Prior-Adaptive Extrapolation  ·  PP-X</a:t>
-            </a:r>
-          </a:p>
-        </p:txBody>
-      </p:sp>
-      <p:sp>
-        <p:nvSpPr>
-          <p:cNvPr id="11" name="TextBox 10"/>
-          <p:cNvSpPr txBox="1"/>
-          <p:nvPr/>
-        </p:nvSpPr>
-        <p:spPr>
-          <a:xfrm>
-            <a:off x="10477500" y="6515100"/>
-            <a:ext cx="952500" cy="152400"/>
-          </a:xfrm>
-          <a:prstGeom prst="rect">
-            <a:avLst/>
-          </a:prstGeom>
-          <a:noFill/>
-        </p:spPr>
-        <p:txBody>
-          <a:bodyPr wrap="square">
-            <a:spAutoFit/>
-          </a:bodyPr>
-          <a:lstStyle/>
-          <a:p>
-            <a:pPr algn="r"/>
-            <a:r>
-              <a:rPr sz="1000" b="1">
-                <a:solidFill>
-                  <a:srgbClr val="666666"/>
-                </a:solidFill>
-                <a:latin typeface="Arial"/>
-                <a:ea typeface="AppleGothic"/>
-              </a:rPr>
-              <a:t>15/42</a:t>
-            </a:r>
-          </a:p>
-        </p:txBody>
-      </p:sp>
-    </p:spTree>
-  </p:cSld>
-  <p:clrMapOvr>
-    <a:masterClrMapping/>
-  </p:clrMapOvr>
-</p:sld>
-</file>
-
 <file path=ppt/slides/slide16.xml><?xml version="1.0" encoding="utf-8"?>
 <p:sld xmlns:a="http://schemas.openxmlformats.org/drawingml/2006/main" xmlns:p="http://schemas.openxmlformats.org/presentationml/2006/main" xmlns:r="http://schemas.openxmlformats.org/officeDocument/2006/relationships">
   <p:cSld>
@@ -14389,386 +11240,6 @@
                 <a:ea typeface="AppleGothic"/>
               </a:rPr>
               <a:t>16/42</a:t>
-            </a:r>
-          </a:p>
-        </p:txBody>
-      </p:sp>
-    </p:spTree>
-  </p:cSld>
-  <p:clrMapOvr>
-    <a:masterClrMapping/>
-  </p:clrMapOvr>
-</p:sld>
-</file>
-
-<file path=ppt/slides/slide17.xml><?xml version="1.0" encoding="utf-8"?>
-<p:sld xmlns:a="http://schemas.openxmlformats.org/drawingml/2006/main" xmlns:p="http://schemas.openxmlformats.org/presentationml/2006/main" xmlns:r="http://schemas.openxmlformats.org/officeDocument/2006/relationships">
-  <p:cSld>
-    <p:spTree>
-      <p:nvGrpSpPr>
-        <p:cNvPr id="1" name=""/>
-        <p:cNvGrpSpPr/>
-        <p:nvPr/>
-      </p:nvGrpSpPr>
-      <p:grpSpPr/>
-      <p:sp>
-        <p:nvSpPr>
-          <p:cNvPr id="2" name="Rectangle 1"/>
-          <p:cNvSpPr/>
-          <p:nvPr/>
-        </p:nvSpPr>
-        <p:spPr>
-          <a:xfrm>
-            <a:off x="0" y="0"/>
-            <a:ext cx="12192000" cy="6858000"/>
-          </a:xfrm>
-          <a:prstGeom prst="rect">
-            <a:avLst/>
-          </a:prstGeom>
-          <a:solidFill>
-            <a:srgbClr val="FFFFFF"/>
-          </a:solidFill>
-          <a:ln>
-            <a:noFill/>
-          </a:ln>
-        </p:spPr>
-        <p:style>
-          <a:lnRef idx="1">
-            <a:schemeClr val="accent1"/>
-          </a:lnRef>
-          <a:fillRef idx="3">
-            <a:schemeClr val="accent1"/>
-          </a:fillRef>
-          <a:effectRef idx="2">
-            <a:schemeClr val="accent1"/>
-          </a:effectRef>
-          <a:fontRef idx="minor">
-            <a:schemeClr val="lt1"/>
-          </a:fontRef>
-        </p:style>
-        <p:txBody>
-          <a:bodyPr rtlCol="0" anchor="ctr"/>
-          <a:lstStyle/>
-          <a:p>
-            <a:pPr algn="ctr"/>
-          </a:p>
-        </p:txBody>
-      </p:sp>
-      <p:sp>
-        <p:nvSpPr>
-          <p:cNvPr id="3" name="Rectangle 2"/>
-          <p:cNvSpPr/>
-          <p:nvPr/>
-        </p:nvSpPr>
-        <p:spPr>
-          <a:xfrm>
-            <a:off x="0" y="0"/>
-            <a:ext cx="12192000" cy="19050"/>
-          </a:xfrm>
-          <a:prstGeom prst="rect">
-            <a:avLst/>
-          </a:prstGeom>
-          <a:solidFill>
-            <a:srgbClr val="222222"/>
-          </a:solidFill>
-          <a:ln>
-            <a:noFill/>
-          </a:ln>
-        </p:spPr>
-        <p:style>
-          <a:lnRef idx="1">
-            <a:schemeClr val="accent1"/>
-          </a:lnRef>
-          <a:fillRef idx="3">
-            <a:schemeClr val="accent1"/>
-          </a:fillRef>
-          <a:effectRef idx="2">
-            <a:schemeClr val="accent1"/>
-          </a:effectRef>
-          <a:fontRef idx="minor">
-            <a:schemeClr val="lt1"/>
-          </a:fontRef>
-        </p:style>
-        <p:txBody>
-          <a:bodyPr rtlCol="0" anchor="ctr"/>
-          <a:lstStyle/>
-          <a:p>
-            <a:pPr algn="ctr"/>
-          </a:p>
-        </p:txBody>
-      </p:sp>
-      <p:sp>
-        <p:nvSpPr>
-          <p:cNvPr id="4" name="TextBox 3"/>
-          <p:cNvSpPr txBox="1"/>
-          <p:nvPr/>
-        </p:nvSpPr>
-        <p:spPr>
-          <a:xfrm>
-            <a:off x="457200" y="209550"/>
-            <a:ext cx="11239500" cy="304800"/>
-          </a:xfrm>
-          <a:prstGeom prst="rect">
-            <a:avLst/>
-          </a:prstGeom>
-          <a:noFill/>
-        </p:spPr>
-        <p:txBody>
-          <a:bodyPr wrap="square">
-            <a:spAutoFit/>
-          </a:bodyPr>
-          <a:lstStyle/>
-          <a:p>
-            <a:pPr algn="l"/>
-            <a:r>
-              <a:rPr sz="2200" b="1">
-                <a:solidFill>
-                  <a:srgbClr val="222222"/>
-                </a:solidFill>
-                <a:latin typeface="Arial"/>
-                <a:ea typeface="AppleGothic"/>
-              </a:rPr>
-              <a:t>Ablation — 대조군 · history</a:t>
-            </a:r>
-          </a:p>
-        </p:txBody>
-      </p:sp>
-      <p:sp>
-        <p:nvSpPr>
-          <p:cNvPr id="5" name="TextBox 4"/>
-          <p:cNvSpPr txBox="1"/>
-          <p:nvPr/>
-        </p:nvSpPr>
-        <p:spPr>
-          <a:xfrm>
-            <a:off x="457200" y="514350"/>
-            <a:ext cx="11239500" cy="190500"/>
-          </a:xfrm>
-          <a:prstGeom prst="rect">
-            <a:avLst/>
-          </a:prstGeom>
-          <a:noFill/>
-        </p:spPr>
-        <p:txBody>
-          <a:bodyPr wrap="square">
-            <a:spAutoFit/>
-          </a:bodyPr>
-          <a:lstStyle/>
-          <a:p>
-            <a:pPr algn="l"/>
-            <a:r>
-              <a:rPr sz="1200" b="0">
-                <a:solidFill>
-                  <a:srgbClr val="666666"/>
-                </a:solidFill>
-                <a:latin typeface="Arial"/>
-                <a:ea typeface="AppleGothic"/>
-              </a:rPr>
-              <a:t>(a) matched 6-arm  ·  (b) causal history</a:t>
-            </a:r>
-          </a:p>
-        </p:txBody>
-      </p:sp>
-      <p:pic>
-        <p:nvPicPr>
-          <p:cNvPr id="6" name="Picture 5" descr="ablation_arms.png"/>
-          <p:cNvPicPr>
-            <a:picLocks noChangeAspect="1"/>
-          </p:cNvPicPr>
-          <p:nvPr/>
-        </p:nvPicPr>
-        <p:blipFill>
-          <a:blip r:embed="rId2"/>
-          <a:stretch>
-            <a:fillRect/>
-          </a:stretch>
-        </p:blipFill>
-        <p:spPr>
-          <a:xfrm>
-            <a:off x="190500" y="838200"/>
-            <a:ext cx="6000750" cy="3810000"/>
-          </a:xfrm>
-          <a:prstGeom prst="rect">
-            <a:avLst/>
-          </a:prstGeom>
-        </p:spPr>
-      </p:pic>
-      <p:pic>
-        <p:nvPicPr>
-          <p:cNvPr id="7" name="Picture 6" descr="ablation_history.png"/>
-          <p:cNvPicPr>
-            <a:picLocks noChangeAspect="1"/>
-          </p:cNvPicPr>
-          <p:nvPr/>
-        </p:nvPicPr>
-        <p:blipFill>
-          <a:blip r:embed="rId3"/>
-          <a:stretch>
-            <a:fillRect/>
-          </a:stretch>
-        </p:blipFill>
-        <p:spPr>
-          <a:xfrm>
-            <a:off x="6191250" y="838200"/>
-            <a:ext cx="5715000" cy="3619500"/>
-          </a:xfrm>
-          <a:prstGeom prst="rect">
-            <a:avLst/>
-          </a:prstGeom>
-        </p:spPr>
-      </p:pic>
-      <p:sp>
-        <p:nvSpPr>
-          <p:cNvPr id="8" name="TextBox 7"/>
-          <p:cNvSpPr txBox="1"/>
-          <p:nvPr/>
-        </p:nvSpPr>
-        <p:spPr>
-          <a:xfrm>
-            <a:off x="457200" y="4762500"/>
-            <a:ext cx="11239500" cy="762000"/>
-          </a:xfrm>
-          <a:prstGeom prst="rect">
-            <a:avLst/>
-          </a:prstGeom>
-          <a:noFill/>
-        </p:spPr>
-        <p:txBody>
-          <a:bodyPr wrap="square">
-            <a:spAutoFit/>
-          </a:bodyPr>
-          <a:lstStyle/>
-          <a:p>
-            <a:pPr algn="l"/>
-            <a:r>
-              <a:rPr sz="1300" b="0">
-                <a:solidFill>
-                  <a:srgbClr val="222222"/>
-                </a:solidFill>
-                <a:latin typeface="Arial"/>
-                <a:ea typeface="AppleGothic"/>
-              </a:rPr>
-              <a:t>(a) 결론  Affine만, 또는 그냥 NN만으로는 부족하다. 동결 affine 위에 제한 residual을 올린 조합이 세 셋에서 가장 안정하다.</a:t>
-            </a:r>
-          </a:p>
-          <a:p>
-            <a:pPr algn="l"/>
-            <a:r>
-              <a:rPr sz="1300" b="0">
-                <a:solidFill>
-                  <a:srgbClr val="222222"/>
-                </a:solidFill>
-                <a:latin typeface="Arial"/>
-                <a:ea typeface="AppleGothic"/>
-              </a:rPr>
-              <a:t>(b) 결론  속도 이력은 Sun·RWTH에 필요하고, MICH에서는 단순한 margin history가 더 높다(0.715 vs 0.468). 이력을 전역 기본값으로 두지 않는다.</a:t>
-            </a:r>
-          </a:p>
-        </p:txBody>
-      </p:sp>
-      <p:cxnSp>
-        <p:nvCxnSpPr>
-          <p:cNvPr id="9" name="Connector 8"/>
-          <p:cNvCxnSpPr/>
-          <p:nvPr/>
-        </p:nvCxnSpPr>
-        <p:spPr>
-          <a:xfrm>
-            <a:off x="457200" y="6477000"/>
-            <a:ext cx="11277600" cy="0"/>
-          </a:xfrm>
-          <a:prstGeom prst="line">
-            <a:avLst/>
-          </a:prstGeom>
-          <a:ln w="9525">
-            <a:solidFill>
-              <a:srgbClr val="E8E8E8"/>
-            </a:solidFill>
-          </a:ln>
-        </p:spPr>
-        <p:style>
-          <a:lnRef idx="2">
-            <a:schemeClr val="accent1"/>
-          </a:lnRef>
-          <a:fillRef idx="0">
-            <a:schemeClr val="accent1"/>
-          </a:fillRef>
-          <a:effectRef idx="1">
-            <a:schemeClr val="accent1"/>
-          </a:effectRef>
-          <a:fontRef idx="minor">
-            <a:schemeClr val="tx1"/>
-          </a:fontRef>
-        </p:style>
-      </p:cxnSp>
-      <p:sp>
-        <p:nvSpPr>
-          <p:cNvPr id="10" name="TextBox 9"/>
-          <p:cNvSpPr txBox="1"/>
-          <p:nvPr/>
-        </p:nvSpPr>
-        <p:spPr>
-          <a:xfrm>
-            <a:off x="457200" y="6534150"/>
-            <a:ext cx="7620000" cy="133350"/>
-          </a:xfrm>
-          <a:prstGeom prst="rect">
-            <a:avLst/>
-          </a:prstGeom>
-          <a:noFill/>
-        </p:spPr>
-        <p:txBody>
-          <a:bodyPr wrap="square">
-            <a:spAutoFit/>
-          </a:bodyPr>
-          <a:lstStyle/>
-          <a:p>
-            <a:pPr algn="l"/>
-            <a:r>
-              <a:rPr sz="900" b="0">
-                <a:solidFill>
-                  <a:srgbClr val="666666"/>
-                </a:solidFill>
-                <a:latin typeface="Arial"/>
-                <a:ea typeface="AppleGothic"/>
-              </a:rPr>
-              <a:t>SPS Lab  ·  Prior-Adaptive Extrapolation  ·  PP-X</a:t>
-            </a:r>
-          </a:p>
-        </p:txBody>
-      </p:sp>
-      <p:sp>
-        <p:nvSpPr>
-          <p:cNvPr id="11" name="TextBox 10"/>
-          <p:cNvSpPr txBox="1"/>
-          <p:nvPr/>
-        </p:nvSpPr>
-        <p:spPr>
-          <a:xfrm>
-            <a:off x="10477500" y="6515100"/>
-            <a:ext cx="952500" cy="152400"/>
-          </a:xfrm>
-          <a:prstGeom prst="rect">
-            <a:avLst/>
-          </a:prstGeom>
-          <a:noFill/>
-        </p:spPr>
-        <p:txBody>
-          <a:bodyPr wrap="square">
-            <a:spAutoFit/>
-          </a:bodyPr>
-          <a:lstStyle/>
-          <a:p>
-            <a:pPr algn="r"/>
-            <a:r>
-              <a:rPr sz="1000" b="1">
-                <a:solidFill>
-                  <a:srgbClr val="666666"/>
-                </a:solidFill>
-                <a:latin typeface="Arial"/>
-                <a:ea typeface="AppleGothic"/>
-              </a:rPr>
-              <a:t>17/42</a:t>
             </a:r>
           </a:p>
         </p:txBody>
@@ -43667,1286 +40138,7 @@
                 <a:latin typeface="Arial"/>
                 <a:ea typeface="AppleGothic"/>
               </a:rPr>
-              <a:t>weak prior + bounded residual</a:t>
-            </a:r>
-          </a:p>
-          <a:p>
-            <a:pPr algn="ctr"/>
-            <a:r>
-              <a:rPr sz="1200" b="0">
-                <a:solidFill>
-                  <a:srgbClr val="222222"/>
-                </a:solidFill>
-                <a:latin typeface="Arial"/>
-                <a:ea typeface="AppleGothic"/>
-              </a:rPr>
-              <a:t>Validation evidence로 executor 승인 · 실패 시 fallback</a:t>
-            </a:r>
-          </a:p>
-        </p:txBody>
-      </p:sp>
-      <p:sp>
-        <p:nvSpPr>
-          <p:cNvPr id="22" name="Rounded Rectangle 21"/>
-          <p:cNvSpPr/>
-          <p:nvPr/>
-        </p:nvSpPr>
-        <p:spPr>
-          <a:xfrm>
-            <a:off x="6781800" y="3105150"/>
-            <a:ext cx="4953000" cy="1390650"/>
-          </a:xfrm>
-          <a:prstGeom prst="roundRect">
-            <a:avLst>
-              <a:gd name="adj" fmla="val 12000"/>
-            </a:avLst>
-          </a:prstGeom>
-          <a:solidFill>
-            <a:srgbClr val="FDF4E3"/>
-          </a:solidFill>
-          <a:ln w="15875">
-            <a:solidFill>
-              <a:srgbClr val="E69F00"/>
-            </a:solidFill>
-          </a:ln>
-        </p:spPr>
-        <p:style>
-          <a:lnRef idx="1">
-            <a:schemeClr val="accent1"/>
-          </a:lnRef>
-          <a:fillRef idx="3">
-            <a:schemeClr val="accent1"/>
-          </a:fillRef>
-          <a:effectRef idx="2">
-            <a:schemeClr val="accent1"/>
-          </a:effectRef>
-          <a:fontRef idx="minor">
-            <a:schemeClr val="lt1"/>
-          </a:fontRef>
-        </p:style>
-        <p:txBody>
-          <a:bodyPr rtlCol="0" anchor="ctr"/>
-          <a:lstStyle/>
-          <a:p>
-            <a:pPr algn="ctr"/>
-          </a:p>
-        </p:txBody>
-      </p:sp>
-      <p:sp>
-        <p:nvSpPr>
-          <p:cNvPr id="23" name="TextBox 22"/>
-          <p:cNvSpPr txBox="1"/>
-          <p:nvPr/>
-        </p:nvSpPr>
-        <p:spPr>
-          <a:xfrm>
-            <a:off x="6953250" y="3219450"/>
-            <a:ext cx="4610100" cy="266700"/>
-          </a:xfrm>
-          <a:prstGeom prst="rect">
-            <a:avLst/>
-          </a:prstGeom>
-          <a:noFill/>
-        </p:spPr>
-        <p:txBody>
-          <a:bodyPr wrap="square">
-            <a:spAutoFit/>
-          </a:bodyPr>
-          <a:lstStyle/>
-          <a:p>
-            <a:pPr algn="ctr"/>
-            <a:r>
-              <a:rPr sz="1600" b="1">
-                <a:solidFill>
-                  <a:srgbClr val="E69F00"/>
-                </a:solidFill>
-                <a:latin typeface="Arial"/>
-                <a:ea typeface="AppleGothic"/>
-              </a:rPr>
-              <a:t>PAE  |  검증된 식이 있을 때</a:t>
-            </a:r>
-          </a:p>
-        </p:txBody>
-      </p:sp>
-      <p:sp>
-        <p:nvSpPr>
-          <p:cNvPr id="24" name="TextBox 23"/>
-          <p:cNvSpPr txBox="1"/>
-          <p:nvPr/>
-        </p:nvSpPr>
-        <p:spPr>
-          <a:xfrm>
-            <a:off x="7010400" y="3600450"/>
-            <a:ext cx="4495800" cy="628650"/>
-          </a:xfrm>
-          <a:prstGeom prst="rect">
-            <a:avLst/>
-          </a:prstGeom>
-          <a:noFill/>
-        </p:spPr>
-        <p:txBody>
-          <a:bodyPr wrap="square">
-            <a:spAutoFit/>
-          </a:bodyPr>
-          <a:lstStyle/>
-          <a:p>
-            <a:pPr algn="ctr"/>
-            <a:r>
-              <a:rPr sz="1200" b="0">
-                <a:solidFill>
-                  <a:srgbClr val="222222"/>
-                </a:solidFill>
-                <a:latin typeface="Arial"/>
-                <a:ea typeface="AppleGothic"/>
-              </a:rPr>
-              <a:t>validated equation + 제한 NN</a:t>
-            </a:r>
-          </a:p>
-          <a:p>
-            <a:pPr algn="ctr"/>
-            <a:r>
-              <a:rPr sz="1200" b="0">
-                <a:solidFill>
-                  <a:srgbClr val="222222"/>
-                </a:solidFill>
-                <a:latin typeface="Arial"/>
-                <a:ea typeface="AppleGothic"/>
-              </a:rPr>
-              <a:t>source gate · 이득 없으면 PP-X로 복귀</a:t>
-            </a:r>
-          </a:p>
-        </p:txBody>
-      </p:sp>
-      <p:sp>
-        <p:nvSpPr>
-          <p:cNvPr id="25" name="Down Arrow 24"/>
-          <p:cNvSpPr/>
-          <p:nvPr/>
-        </p:nvSpPr>
-        <p:spPr>
-          <a:xfrm>
-            <a:off x="2762250" y="4552950"/>
-            <a:ext cx="342900" cy="304800"/>
-          </a:xfrm>
-          <a:prstGeom prst="downArrow">
-            <a:avLst/>
-          </a:prstGeom>
-          <a:solidFill>
-            <a:srgbClr val="666666"/>
-          </a:solidFill>
-          <a:ln>
-            <a:noFill/>
-          </a:ln>
-        </p:spPr>
-        <p:style>
-          <a:lnRef idx="1">
-            <a:schemeClr val="accent1"/>
-          </a:lnRef>
-          <a:fillRef idx="3">
-            <a:schemeClr val="accent1"/>
-          </a:fillRef>
-          <a:effectRef idx="2">
-            <a:schemeClr val="accent1"/>
-          </a:effectRef>
-          <a:fontRef idx="minor">
-            <a:schemeClr val="lt1"/>
-          </a:fontRef>
-        </p:style>
-        <p:txBody>
-          <a:bodyPr rtlCol="0" anchor="ctr"/>
-          <a:lstStyle/>
-          <a:p>
-            <a:pPr algn="ctr"/>
-          </a:p>
-        </p:txBody>
-      </p:sp>
-      <p:sp>
-        <p:nvSpPr>
-          <p:cNvPr id="26" name="Down Arrow 25"/>
-          <p:cNvSpPr/>
-          <p:nvPr/>
-        </p:nvSpPr>
-        <p:spPr>
-          <a:xfrm>
-            <a:off x="9086850" y="4552950"/>
-            <a:ext cx="342900" cy="304800"/>
-          </a:xfrm>
-          <a:prstGeom prst="downArrow">
-            <a:avLst/>
-          </a:prstGeom>
-          <a:solidFill>
-            <a:srgbClr val="666666"/>
-          </a:solidFill>
-          <a:ln>
-            <a:noFill/>
-          </a:ln>
-        </p:spPr>
-        <p:style>
-          <a:lnRef idx="1">
-            <a:schemeClr val="accent1"/>
-          </a:lnRef>
-          <a:fillRef idx="3">
-            <a:schemeClr val="accent1"/>
-          </a:fillRef>
-          <a:effectRef idx="2">
-            <a:schemeClr val="accent1"/>
-          </a:effectRef>
-          <a:fontRef idx="minor">
-            <a:schemeClr val="lt1"/>
-          </a:fontRef>
-        </p:style>
-        <p:txBody>
-          <a:bodyPr rtlCol="0" anchor="ctr"/>
-          <a:lstStyle/>
-          <a:p>
-            <a:pPr algn="ctr"/>
-          </a:p>
-        </p:txBody>
-      </p:sp>
-      <p:sp>
-        <p:nvSpPr>
-          <p:cNvPr id="27" name="Rounded Rectangle 26"/>
-          <p:cNvSpPr/>
-          <p:nvPr/>
-        </p:nvSpPr>
-        <p:spPr>
-          <a:xfrm>
-            <a:off x="2266950" y="4914900"/>
-            <a:ext cx="7658100" cy="590550"/>
-          </a:xfrm>
-          <a:prstGeom prst="roundRect">
-            <a:avLst>
-              <a:gd name="adj" fmla="val 12000"/>
-            </a:avLst>
-          </a:prstGeom>
-          <a:solidFill>
-            <a:srgbClr val="FFFFFF"/>
-          </a:solidFill>
-          <a:ln w="15875">
-            <a:solidFill>
-              <a:srgbClr val="222222"/>
-            </a:solidFill>
-          </a:ln>
-        </p:spPr>
-        <p:style>
-          <a:lnRef idx="1">
-            <a:schemeClr val="accent1"/>
-          </a:lnRef>
-          <a:fillRef idx="3">
-            <a:schemeClr val="accent1"/>
-          </a:fillRef>
-          <a:effectRef idx="2">
-            <a:schemeClr val="accent1"/>
-          </a:effectRef>
-          <a:fontRef idx="minor">
-            <a:schemeClr val="lt1"/>
-          </a:fontRef>
-        </p:style>
-        <p:txBody>
-          <a:bodyPr rtlCol="0" anchor="ctr"/>
-          <a:lstStyle/>
-          <a:p>
-            <a:pPr algn="ctr"/>
-          </a:p>
-        </p:txBody>
-      </p:sp>
-      <p:sp>
-        <p:nvSpPr>
-          <p:cNvPr id="28" name="TextBox 27"/>
-          <p:cNvSpPr txBox="1"/>
-          <p:nvPr/>
-        </p:nvSpPr>
-        <p:spPr>
-          <a:xfrm>
-            <a:off x="2400300" y="5010150"/>
-            <a:ext cx="7391400" cy="361950"/>
-          </a:xfrm>
-          <a:prstGeom prst="rect">
-            <a:avLst/>
-          </a:prstGeom>
-          <a:noFill/>
-        </p:spPr>
-        <p:txBody>
-          <a:bodyPr wrap="square">
-            <a:spAutoFit/>
-          </a:bodyPr>
-          <a:lstStyle/>
-          <a:p>
-            <a:pPr algn="ctr"/>
-            <a:r>
-              <a:rPr sz="1300" b="1">
-                <a:solidFill>
-                  <a:srgbClr val="222222"/>
-                </a:solidFill>
-                <a:latin typeface="Arial"/>
-                <a:ea typeface="AppleGothic"/>
-              </a:rPr>
-              <a:t>공통 Assurance  ·  믿기 / 보류 / 거절  →  두 경로를 하나의 외삽 프레임워크로 통합</a:t>
-            </a:r>
-          </a:p>
-        </p:txBody>
-      </p:sp>
-      <p:sp>
-        <p:nvSpPr>
-          <p:cNvPr id="29" name="TextBox 28"/>
-          <p:cNvSpPr txBox="1"/>
-          <p:nvPr/>
-        </p:nvSpPr>
-        <p:spPr>
-          <a:xfrm>
-            <a:off x="457200" y="5638800"/>
-            <a:ext cx="11277600" cy="228600"/>
-          </a:xfrm>
-          <a:prstGeom prst="rect">
-            <a:avLst/>
-          </a:prstGeom>
-          <a:noFill/>
-        </p:spPr>
-        <p:txBody>
-          <a:bodyPr wrap="square">
-            <a:spAutoFit/>
-          </a:bodyPr>
-          <a:lstStyle/>
-          <a:p>
-            <a:pPr algn="ctr"/>
-            <a:r>
-              <a:rPr sz="1200" b="1">
-                <a:solidFill>
-                  <a:srgbClr val="666666"/>
-                </a:solidFill>
-                <a:latin typeface="Arial"/>
-                <a:ea typeface="AppleGothic"/>
-              </a:rPr>
-              <a:t>현재 발표 범위: PP-X  ·  후속 확장: PAE + 통합 Assurance</a:t>
-            </a:r>
-          </a:p>
-        </p:txBody>
-      </p:sp>
-      <p:cxnSp>
-        <p:nvCxnSpPr>
-          <p:cNvPr id="30" name="Connector 29"/>
-          <p:cNvCxnSpPr/>
-          <p:nvPr/>
-        </p:nvCxnSpPr>
-        <p:spPr>
-          <a:xfrm>
-            <a:off x="457200" y="6477000"/>
-            <a:ext cx="11277600" cy="0"/>
-          </a:xfrm>
-          <a:prstGeom prst="line">
-            <a:avLst/>
-          </a:prstGeom>
-          <a:ln w="9525">
-            <a:solidFill>
-              <a:srgbClr val="E8E8E8"/>
-            </a:solidFill>
-          </a:ln>
-        </p:spPr>
-        <p:style>
-          <a:lnRef idx="2">
-            <a:schemeClr val="accent1"/>
-          </a:lnRef>
-          <a:fillRef idx="0">
-            <a:schemeClr val="accent1"/>
-          </a:fillRef>
-          <a:effectRef idx="1">
-            <a:schemeClr val="accent1"/>
-          </a:effectRef>
-          <a:fontRef idx="minor">
-            <a:schemeClr val="tx1"/>
-          </a:fontRef>
-        </p:style>
-      </p:cxnSp>
-      <p:sp>
-        <p:nvSpPr>
-          <p:cNvPr id="31" name="TextBox 30"/>
-          <p:cNvSpPr txBox="1"/>
-          <p:nvPr/>
-        </p:nvSpPr>
-        <p:spPr>
-          <a:xfrm>
-            <a:off x="457200" y="6534150"/>
-            <a:ext cx="7620000" cy="133350"/>
-          </a:xfrm>
-          <a:prstGeom prst="rect">
-            <a:avLst/>
-          </a:prstGeom>
-          <a:noFill/>
-        </p:spPr>
-        <p:txBody>
-          <a:bodyPr wrap="square">
-            <a:spAutoFit/>
-          </a:bodyPr>
-          <a:lstStyle/>
-          <a:p>
-            <a:pPr algn="l"/>
-            <a:r>
-              <a:rPr sz="900" b="0">
-                <a:solidFill>
-                  <a:srgbClr val="666666"/>
-                </a:solidFill>
-                <a:latin typeface="Arial"/>
-                <a:ea typeface="AppleGothic"/>
-              </a:rPr>
-              <a:t>SPS Lab  ·  Prior-Adaptive Extrapolation  ·  PP-X</a:t>
-            </a:r>
-          </a:p>
-        </p:txBody>
-      </p:sp>
-      <p:sp>
-        <p:nvSpPr>
-          <p:cNvPr id="32" name="TextBox 31"/>
-          <p:cNvSpPr txBox="1"/>
-          <p:nvPr/>
-        </p:nvSpPr>
-        <p:spPr>
-          <a:xfrm>
-            <a:off x="10477500" y="6515100"/>
-            <a:ext cx="952500" cy="152400"/>
-          </a:xfrm>
-          <a:prstGeom prst="rect">
-            <a:avLst/>
-          </a:prstGeom>
-          <a:noFill/>
-        </p:spPr>
-        <p:txBody>
-          <a:bodyPr wrap="square">
-            <a:spAutoFit/>
-          </a:bodyPr>
-          <a:lstStyle/>
-          <a:p>
-            <a:pPr algn="r"/>
-            <a:r>
-              <a:rPr sz="1000" b="1">
-                <a:solidFill>
-                  <a:srgbClr val="666666"/>
-                </a:solidFill>
-                <a:latin typeface="Arial"/>
-                <a:ea typeface="AppleGothic"/>
-              </a:rPr>
-              <a:t>4/42</a:t>
-            </a:r>
-          </a:p>
-        </p:txBody>
-      </p:sp>
-    </p:spTree>
-  </p:cSld>
-  <p:clrMapOvr>
-    <a:masterClrMapping/>
-  </p:clrMapOvr>
-</p:sld>
-</file>
-
-<file path=ppt/slides/slide4.xml><?xml version="1.0" encoding="utf-8"?>
-<p:sld xmlns:a="http://schemas.openxmlformats.org/drawingml/2006/main" xmlns:p="http://schemas.openxmlformats.org/presentationml/2006/main" xmlns:r="http://schemas.openxmlformats.org/officeDocument/2006/relationships">
-  <p:cSld>
-    <p:spTree>
-      <p:nvGrpSpPr>
-        <p:cNvPr id="1" name=""/>
-        <p:cNvGrpSpPr/>
-        <p:nvPr/>
-      </p:nvGrpSpPr>
-      <p:grpSpPr/>
-      <p:sp>
-        <p:nvSpPr>
-          <p:cNvPr id="2" name="Rectangle 1"/>
-          <p:cNvSpPr/>
-          <p:nvPr/>
-        </p:nvSpPr>
-        <p:spPr>
-          <a:xfrm>
-            <a:off x="0" y="0"/>
-            <a:ext cx="12192000" cy="6858000"/>
-          </a:xfrm>
-          <a:prstGeom prst="rect">
-            <a:avLst/>
-          </a:prstGeom>
-          <a:solidFill>
-            <a:srgbClr val="FFFFFF"/>
-          </a:solidFill>
-          <a:ln>
-            <a:noFill/>
-          </a:ln>
-        </p:spPr>
-        <p:style>
-          <a:lnRef idx="1">
-            <a:schemeClr val="accent1"/>
-          </a:lnRef>
-          <a:fillRef idx="3">
-            <a:schemeClr val="accent1"/>
-          </a:fillRef>
-          <a:effectRef idx="2">
-            <a:schemeClr val="accent1"/>
-          </a:effectRef>
-          <a:fontRef idx="minor">
-            <a:schemeClr val="lt1"/>
-          </a:fontRef>
-        </p:style>
-        <p:txBody>
-          <a:bodyPr rtlCol="0" anchor="ctr"/>
-          <a:lstStyle/>
-          <a:p>
-            <a:pPr algn="ctr"/>
-          </a:p>
-        </p:txBody>
-      </p:sp>
-      <p:sp>
-        <p:nvSpPr>
-          <p:cNvPr id="3" name="Rectangle 2"/>
-          <p:cNvSpPr/>
-          <p:nvPr/>
-        </p:nvSpPr>
-        <p:spPr>
-          <a:xfrm>
-            <a:off x="0" y="0"/>
-            <a:ext cx="12192000" cy="19050"/>
-          </a:xfrm>
-          <a:prstGeom prst="rect">
-            <a:avLst/>
-          </a:prstGeom>
-          <a:solidFill>
-            <a:srgbClr val="222222"/>
-          </a:solidFill>
-          <a:ln>
-            <a:noFill/>
-          </a:ln>
-        </p:spPr>
-        <p:style>
-          <a:lnRef idx="1">
-            <a:schemeClr val="accent1"/>
-          </a:lnRef>
-          <a:fillRef idx="3">
-            <a:schemeClr val="accent1"/>
-          </a:fillRef>
-          <a:effectRef idx="2">
-            <a:schemeClr val="accent1"/>
-          </a:effectRef>
-          <a:fontRef idx="minor">
-            <a:schemeClr val="lt1"/>
-          </a:fontRef>
-        </p:style>
-        <p:txBody>
-          <a:bodyPr rtlCol="0" anchor="ctr"/>
-          <a:lstStyle/>
-          <a:p>
-            <a:pPr algn="ctr"/>
-          </a:p>
-        </p:txBody>
-      </p:sp>
-      <p:sp>
-        <p:nvSpPr>
-          <p:cNvPr id="4" name="TextBox 3"/>
-          <p:cNvSpPr txBox="1"/>
-          <p:nvPr/>
-        </p:nvSpPr>
-        <p:spPr>
-          <a:xfrm>
-            <a:off x="457200" y="209550"/>
-            <a:ext cx="11239500" cy="304800"/>
-          </a:xfrm>
-          <a:prstGeom prst="rect">
-            <a:avLst/>
-          </a:prstGeom>
-          <a:noFill/>
-        </p:spPr>
-        <p:txBody>
-          <a:bodyPr wrap="square">
-            <a:spAutoFit/>
-          </a:bodyPr>
-          <a:lstStyle/>
-          <a:p>
-            <a:pPr algn="l"/>
-            <a:r>
-              <a:rPr sz="2200" b="1">
-                <a:solidFill>
-                  <a:srgbClr val="222222"/>
-                </a:solidFill>
-                <a:latin typeface="Arial"/>
-                <a:ea typeface="AppleGothic"/>
-              </a:rPr>
-              <a:t>연구 루트 — 식의 근거에 따라 두 경로로 간다</a:t>
-            </a:r>
-          </a:p>
-        </p:txBody>
-      </p:sp>
-      <p:sp>
-        <p:nvSpPr>
-          <p:cNvPr id="5" name="TextBox 4"/>
-          <p:cNvSpPr txBox="1"/>
-          <p:nvPr/>
-        </p:nvSpPr>
-        <p:spPr>
-          <a:xfrm>
-            <a:off x="457200" y="514350"/>
-            <a:ext cx="11239500" cy="190500"/>
-          </a:xfrm>
-          <a:prstGeom prst="rect">
-            <a:avLst/>
-          </a:prstGeom>
-          <a:noFill/>
-        </p:spPr>
-        <p:txBody>
-          <a:bodyPr wrap="square">
-            <a:spAutoFit/>
-          </a:bodyPr>
-          <a:lstStyle/>
-          <a:p>
-            <a:pPr algn="l"/>
-            <a:r>
-              <a:rPr sz="1200" b="0">
-                <a:solidFill>
-                  <a:srgbClr val="666666"/>
-                </a:solidFill>
-                <a:latin typeface="Arial"/>
-                <a:ea typeface="AppleGothic"/>
-              </a:rPr>
-              <a:t>식이 없거나 약한 prior만 있으면 PP-X, 적용 가능한 식이 정당화되면 PAE로 확장한다.</a:t>
-            </a:r>
-          </a:p>
-        </p:txBody>
-      </p:sp>
-      <p:sp>
-        <p:nvSpPr>
-          <p:cNvPr id="6" name="Rounded Rectangle 5"/>
-          <p:cNvSpPr/>
-          <p:nvPr/>
-        </p:nvSpPr>
-        <p:spPr>
-          <a:xfrm>
-            <a:off x="2266950" y="819150"/>
-            <a:ext cx="7658100" cy="514350"/>
-          </a:xfrm>
-          <a:prstGeom prst="roundRect">
-            <a:avLst>
-              <a:gd name="adj" fmla="val 12000"/>
-            </a:avLst>
-          </a:prstGeom>
-          <a:solidFill>
-            <a:srgbClr val="222222"/>
-          </a:solidFill>
-          <a:ln>
-            <a:noFill/>
-          </a:ln>
-        </p:spPr>
-        <p:style>
-          <a:lnRef idx="1">
-            <a:schemeClr val="accent1"/>
-          </a:lnRef>
-          <a:fillRef idx="3">
-            <a:schemeClr val="accent1"/>
-          </a:fillRef>
-          <a:effectRef idx="2">
-            <a:schemeClr val="accent1"/>
-          </a:effectRef>
-          <a:fontRef idx="minor">
-            <a:schemeClr val="lt1"/>
-          </a:fontRef>
-        </p:style>
-        <p:txBody>
-          <a:bodyPr rtlCol="0" anchor="ctr"/>
-          <a:lstStyle/>
-          <a:p>
-            <a:pPr algn="ctr"/>
-          </a:p>
-        </p:txBody>
-      </p:sp>
-      <p:sp>
-        <p:nvSpPr>
-          <p:cNvPr id="7" name="TextBox 6"/>
-          <p:cNvSpPr txBox="1"/>
-          <p:nvPr/>
-        </p:nvSpPr>
-        <p:spPr>
-          <a:xfrm>
-            <a:off x="2419350" y="914400"/>
-            <a:ext cx="7353300" cy="304800"/>
-          </a:xfrm>
-          <a:prstGeom prst="rect">
-            <a:avLst/>
-          </a:prstGeom>
-          <a:noFill/>
-        </p:spPr>
-        <p:txBody>
-          <a:bodyPr wrap="square">
-            <a:spAutoFit/>
-          </a:bodyPr>
-          <a:lstStyle/>
-          <a:p>
-            <a:pPr algn="ctr"/>
-            <a:r>
-              <a:rPr sz="1600" b="1">
-                <a:solidFill>
-                  <a:srgbClr val="FFFFFF"/>
-                </a:solidFill>
-                <a:latin typeface="Arial"/>
-                <a:ea typeface="AppleGothic"/>
-              </a:rPr>
-              <a:t>목표  ·  근거 수준에 맞는 강건한 외삽 프레임워크 구축</a:t>
-            </a:r>
-          </a:p>
-        </p:txBody>
-      </p:sp>
-      <p:sp>
-        <p:nvSpPr>
-          <p:cNvPr id="8" name="Rounded Rectangle 7"/>
-          <p:cNvSpPr/>
-          <p:nvPr/>
-        </p:nvSpPr>
-        <p:spPr>
-          <a:xfrm>
-            <a:off x="457200" y="1695450"/>
-            <a:ext cx="2381250" cy="819150"/>
-          </a:xfrm>
-          <a:prstGeom prst="roundRect">
-            <a:avLst>
-              <a:gd name="adj" fmla="val 12000"/>
-            </a:avLst>
-          </a:prstGeom>
-          <a:solidFill>
-            <a:srgbClr val="F5F5F5"/>
-          </a:solidFill>
-          <a:ln w="15875">
-            <a:solidFill>
-              <a:srgbClr val="666666"/>
-            </a:solidFill>
-          </a:ln>
-        </p:spPr>
-        <p:style>
-          <a:lnRef idx="1">
-            <a:schemeClr val="accent1"/>
-          </a:lnRef>
-          <a:fillRef idx="3">
-            <a:schemeClr val="accent1"/>
-          </a:fillRef>
-          <a:effectRef idx="2">
-            <a:schemeClr val="accent1"/>
-          </a:effectRef>
-          <a:fontRef idx="minor">
-            <a:schemeClr val="lt1"/>
-          </a:fontRef>
-        </p:style>
-        <p:txBody>
-          <a:bodyPr rtlCol="0" anchor="ctr"/>
-          <a:lstStyle/>
-          <a:p>
-            <a:pPr algn="ctr"/>
-          </a:p>
-        </p:txBody>
-      </p:sp>
-      <p:sp>
-        <p:nvSpPr>
-          <p:cNvPr id="9" name="TextBox 8"/>
-          <p:cNvSpPr txBox="1"/>
-          <p:nvPr/>
-        </p:nvSpPr>
-        <p:spPr>
-          <a:xfrm>
-            <a:off x="590550" y="1790700"/>
-            <a:ext cx="2114550" cy="228600"/>
-          </a:xfrm>
-          <a:prstGeom prst="rect">
-            <a:avLst/>
-          </a:prstGeom>
-          <a:noFill/>
-        </p:spPr>
-        <p:txBody>
-          <a:bodyPr wrap="square">
-            <a:spAutoFit/>
-          </a:bodyPr>
-          <a:lstStyle/>
-          <a:p>
-            <a:pPr algn="ctr"/>
-            <a:r>
-              <a:rPr sz="1200" b="1">
-                <a:solidFill>
-                  <a:srgbClr val="666666"/>
-                </a:solidFill>
-                <a:latin typeface="Arial"/>
-                <a:ea typeface="AppleGothic"/>
-              </a:rPr>
-              <a:t>사용 가능한 근거</a:t>
-            </a:r>
-          </a:p>
-        </p:txBody>
-      </p:sp>
-      <p:sp>
-        <p:nvSpPr>
-          <p:cNvPr id="10" name="TextBox 9"/>
-          <p:cNvSpPr txBox="1"/>
-          <p:nvPr/>
-        </p:nvSpPr>
-        <p:spPr>
-          <a:xfrm>
-            <a:off x="590550" y="2076450"/>
-            <a:ext cx="2114550" cy="304800"/>
-          </a:xfrm>
-          <a:prstGeom prst="rect">
-            <a:avLst/>
-          </a:prstGeom>
-          <a:noFill/>
-        </p:spPr>
-        <p:txBody>
-          <a:bodyPr wrap="square">
-            <a:spAutoFit/>
-          </a:bodyPr>
-          <a:lstStyle/>
-          <a:p>
-            <a:pPr algn="ctr"/>
-            <a:r>
-              <a:rPr sz="1300" b="1">
-                <a:solidFill>
-                  <a:srgbClr val="222222"/>
-                </a:solidFill>
-                <a:latin typeface="Arial"/>
-                <a:ea typeface="AppleGothic"/>
-              </a:rPr>
-              <a:t>관측 · 경계 · 도메인 지식</a:t>
-            </a:r>
-          </a:p>
-        </p:txBody>
-      </p:sp>
-      <p:sp>
-        <p:nvSpPr>
-          <p:cNvPr id="11" name="Right Arrow 10"/>
-          <p:cNvSpPr/>
-          <p:nvPr/>
-        </p:nvSpPr>
-        <p:spPr>
-          <a:xfrm>
-            <a:off x="2914650" y="1952625"/>
-            <a:ext cx="514350" cy="285750"/>
-          </a:xfrm>
-          <a:prstGeom prst="rightArrow">
-            <a:avLst/>
-          </a:prstGeom>
-          <a:solidFill>
-            <a:srgbClr val="666666"/>
-          </a:solidFill>
-          <a:ln>
-            <a:noFill/>
-          </a:ln>
-        </p:spPr>
-        <p:style>
-          <a:lnRef idx="1">
-            <a:schemeClr val="accent1"/>
-          </a:lnRef>
-          <a:fillRef idx="3">
-            <a:schemeClr val="accent1"/>
-          </a:fillRef>
-          <a:effectRef idx="2">
-            <a:schemeClr val="accent1"/>
-          </a:effectRef>
-          <a:fontRef idx="minor">
-            <a:schemeClr val="lt1"/>
-          </a:fontRef>
-        </p:style>
-        <p:txBody>
-          <a:bodyPr rtlCol="0" anchor="ctr"/>
-          <a:lstStyle/>
-          <a:p>
-            <a:pPr algn="ctr"/>
-          </a:p>
-        </p:txBody>
-      </p:sp>
-      <p:sp>
-        <p:nvSpPr>
-          <p:cNvPr id="12" name="Diamond 11"/>
-          <p:cNvSpPr/>
-          <p:nvPr/>
-        </p:nvSpPr>
-        <p:spPr>
-          <a:xfrm>
-            <a:off x="3638550" y="1562100"/>
-            <a:ext cx="2857500" cy="1104900"/>
-          </a:xfrm>
-          <a:prstGeom prst="diamond">
-            <a:avLst/>
-          </a:prstGeom>
-          <a:solidFill>
-            <a:srgbClr val="FDF4E3"/>
-          </a:solidFill>
-          <a:ln w="15875">
-            <a:solidFill>
-              <a:srgbClr val="E69F00"/>
-            </a:solidFill>
-          </a:ln>
-        </p:spPr>
-        <p:style>
-          <a:lnRef idx="1">
-            <a:schemeClr val="accent1"/>
-          </a:lnRef>
-          <a:fillRef idx="3">
-            <a:schemeClr val="accent1"/>
-          </a:fillRef>
-          <a:effectRef idx="2">
-            <a:schemeClr val="accent1"/>
-          </a:effectRef>
-          <a:fontRef idx="minor">
-            <a:schemeClr val="lt1"/>
-          </a:fontRef>
-        </p:style>
-        <p:txBody>
-          <a:bodyPr rtlCol="0" anchor="ctr" wrap="square"/>
-          <a:lstStyle/>
-          <a:p>
-            <a:pPr algn="ctr"/>
-            <a:r>
-              <a:rPr sz="1300" b="1">
-                <a:solidFill>
-                  <a:srgbClr val="222222"/>
-                </a:solidFill>
-                <a:latin typeface="Arial"/>
-                <a:ea typeface="AppleGothic"/>
-              </a:rPr>
-              <a:t>적용 가능한 후보식이
-정당화되는가?</a:t>
-            </a:r>
-          </a:p>
-        </p:txBody>
-      </p:sp>
-      <p:cxnSp>
-        <p:nvCxnSpPr>
-          <p:cNvPr id="13" name="Connector 12"/>
-          <p:cNvCxnSpPr/>
-          <p:nvPr/>
-        </p:nvCxnSpPr>
-        <p:spPr>
-          <a:xfrm>
-            <a:off x="5067300" y="2667000"/>
-            <a:ext cx="0" cy="114300"/>
-          </a:xfrm>
-          <a:prstGeom prst="line">
-            <a:avLst/>
-          </a:prstGeom>
-          <a:ln w="15875">
-            <a:solidFill>
-              <a:srgbClr val="666666"/>
-            </a:solidFill>
-          </a:ln>
-        </p:spPr>
-        <p:style>
-          <a:lnRef idx="2">
-            <a:schemeClr val="accent1"/>
-          </a:lnRef>
-          <a:fillRef idx="0">
-            <a:schemeClr val="accent1"/>
-          </a:fillRef>
-          <a:effectRef idx="1">
-            <a:schemeClr val="accent1"/>
-          </a:effectRef>
-          <a:fontRef idx="minor">
-            <a:schemeClr val="tx1"/>
-          </a:fontRef>
-        </p:style>
-      </p:cxnSp>
-      <p:cxnSp>
-        <p:nvCxnSpPr>
-          <p:cNvPr id="14" name="Connector 13"/>
-          <p:cNvCxnSpPr/>
-          <p:nvPr/>
-        </p:nvCxnSpPr>
-        <p:spPr>
-          <a:xfrm>
-            <a:off x="1847850" y="2781300"/>
-            <a:ext cx="6438900" cy="0"/>
-          </a:xfrm>
-          <a:prstGeom prst="line">
-            <a:avLst/>
-          </a:prstGeom>
-          <a:ln w="15875">
-            <a:solidFill>
-              <a:srgbClr val="666666"/>
-            </a:solidFill>
-          </a:ln>
-        </p:spPr>
-        <p:style>
-          <a:lnRef idx="2">
-            <a:schemeClr val="accent1"/>
-          </a:lnRef>
-          <a:fillRef idx="0">
-            <a:schemeClr val="accent1"/>
-          </a:fillRef>
-          <a:effectRef idx="1">
-            <a:schemeClr val="accent1"/>
-          </a:effectRef>
-          <a:fontRef idx="minor">
-            <a:schemeClr val="tx1"/>
-          </a:fontRef>
-        </p:style>
-      </p:cxnSp>
-      <p:sp>
-        <p:nvSpPr>
-          <p:cNvPr id="15" name="Down Arrow 14"/>
-          <p:cNvSpPr/>
-          <p:nvPr/>
-        </p:nvSpPr>
-        <p:spPr>
-          <a:xfrm>
-            <a:off x="1676400" y="2724150"/>
-            <a:ext cx="342900" cy="323850"/>
-          </a:xfrm>
-          <a:prstGeom prst="downArrow">
-            <a:avLst/>
-          </a:prstGeom>
-          <a:solidFill>
-            <a:srgbClr val="0072B2"/>
-          </a:solidFill>
-          <a:ln>
-            <a:noFill/>
-          </a:ln>
-        </p:spPr>
-        <p:style>
-          <a:lnRef idx="1">
-            <a:schemeClr val="accent1"/>
-          </a:lnRef>
-          <a:fillRef idx="3">
-            <a:schemeClr val="accent1"/>
-          </a:fillRef>
-          <a:effectRef idx="2">
-            <a:schemeClr val="accent1"/>
-          </a:effectRef>
-          <a:fontRef idx="minor">
-            <a:schemeClr val="lt1"/>
-          </a:fontRef>
-        </p:style>
-        <p:txBody>
-          <a:bodyPr rtlCol="0" anchor="ctr"/>
-          <a:lstStyle/>
-          <a:p>
-            <a:pPr algn="ctr"/>
-          </a:p>
-        </p:txBody>
-      </p:sp>
-      <p:sp>
-        <p:nvSpPr>
-          <p:cNvPr id="16" name="Down Arrow 15"/>
-          <p:cNvSpPr/>
-          <p:nvPr/>
-        </p:nvSpPr>
-        <p:spPr>
-          <a:xfrm>
-            <a:off x="8115300" y="2724150"/>
-            <a:ext cx="342900" cy="323850"/>
-          </a:xfrm>
-          <a:prstGeom prst="downArrow">
-            <a:avLst/>
-          </a:prstGeom>
-          <a:solidFill>
-            <a:srgbClr val="E69F00"/>
-          </a:solidFill>
-          <a:ln>
-            <a:noFill/>
-          </a:ln>
-        </p:spPr>
-        <p:style>
-          <a:lnRef idx="1">
-            <a:schemeClr val="accent1"/>
-          </a:lnRef>
-          <a:fillRef idx="3">
-            <a:schemeClr val="accent1"/>
-          </a:fillRef>
-          <a:effectRef idx="2">
-            <a:schemeClr val="accent1"/>
-          </a:effectRef>
-          <a:fontRef idx="minor">
-            <a:schemeClr val="lt1"/>
-          </a:fontRef>
-        </p:style>
-        <p:txBody>
-          <a:bodyPr rtlCol="0" anchor="ctr"/>
-          <a:lstStyle/>
-          <a:p>
-            <a:pPr algn="ctr"/>
-          </a:p>
-        </p:txBody>
-      </p:sp>
-      <p:sp>
-        <p:nvSpPr>
-          <p:cNvPr id="17" name="TextBox 16"/>
-          <p:cNvSpPr txBox="1"/>
-          <p:nvPr/>
-        </p:nvSpPr>
-        <p:spPr>
-          <a:xfrm>
-            <a:off x="2095500" y="2647950"/>
-            <a:ext cx="571500" cy="228600"/>
-          </a:xfrm>
-          <a:prstGeom prst="rect">
-            <a:avLst/>
-          </a:prstGeom>
-          <a:noFill/>
-        </p:spPr>
-        <p:txBody>
-          <a:bodyPr wrap="square">
-            <a:spAutoFit/>
-          </a:bodyPr>
-          <a:lstStyle/>
-          <a:p>
-            <a:pPr algn="l"/>
-            <a:r>
-              <a:rPr sz="1200" b="1">
-                <a:solidFill>
-                  <a:srgbClr val="0072B2"/>
-                </a:solidFill>
-                <a:latin typeface="Arial"/>
-                <a:ea typeface="AppleGothic"/>
-              </a:rPr>
-              <a:t>NO</a:t>
-            </a:r>
-          </a:p>
-        </p:txBody>
-      </p:sp>
-      <p:sp>
-        <p:nvSpPr>
-          <p:cNvPr id="18" name="TextBox 17"/>
-          <p:cNvSpPr txBox="1"/>
-          <p:nvPr/>
-        </p:nvSpPr>
-        <p:spPr>
-          <a:xfrm>
-            <a:off x="7467600" y="2647950"/>
-            <a:ext cx="571500" cy="228600"/>
-          </a:xfrm>
-          <a:prstGeom prst="rect">
-            <a:avLst/>
-          </a:prstGeom>
-          <a:noFill/>
-        </p:spPr>
-        <p:txBody>
-          <a:bodyPr wrap="square">
-            <a:spAutoFit/>
-          </a:bodyPr>
-          <a:lstStyle/>
-          <a:p>
-            <a:pPr algn="r"/>
-            <a:r>
-              <a:rPr sz="1200" b="1">
-                <a:solidFill>
-                  <a:srgbClr val="E69F00"/>
-                </a:solidFill>
-                <a:latin typeface="Arial"/>
-                <a:ea typeface="AppleGothic"/>
-              </a:rPr>
-              <a:t>YES</a:t>
-            </a:r>
-          </a:p>
-        </p:txBody>
-      </p:sp>
-      <p:sp>
-        <p:nvSpPr>
-          <p:cNvPr id="19" name="Rounded Rectangle 18"/>
-          <p:cNvSpPr/>
-          <p:nvPr/>
-        </p:nvSpPr>
-        <p:spPr>
-          <a:xfrm>
-            <a:off x="457200" y="3105150"/>
-            <a:ext cx="4953000" cy="1390650"/>
-          </a:xfrm>
-          <a:prstGeom prst="roundRect">
-            <a:avLst>
-              <a:gd name="adj" fmla="val 12000"/>
-            </a:avLst>
-          </a:prstGeom>
-          <a:solidFill>
-            <a:srgbClr val="E8F1F8"/>
-          </a:solidFill>
-          <a:ln w="15875">
-            <a:solidFill>
-              <a:srgbClr val="0072B2"/>
-            </a:solidFill>
-          </a:ln>
-        </p:spPr>
-        <p:style>
-          <a:lnRef idx="1">
-            <a:schemeClr val="accent1"/>
-          </a:lnRef>
-          <a:fillRef idx="3">
-            <a:schemeClr val="accent1"/>
-          </a:fillRef>
-          <a:effectRef idx="2">
-            <a:schemeClr val="accent1"/>
-          </a:effectRef>
-          <a:fontRef idx="minor">
-            <a:schemeClr val="lt1"/>
-          </a:fontRef>
-        </p:style>
-        <p:txBody>
-          <a:bodyPr rtlCol="0" anchor="ctr"/>
-          <a:lstStyle/>
-          <a:p>
-            <a:pPr algn="ctr"/>
-          </a:p>
-        </p:txBody>
-      </p:sp>
-      <p:sp>
-        <p:nvSpPr>
-          <p:cNvPr id="20" name="TextBox 19"/>
-          <p:cNvSpPr txBox="1"/>
-          <p:nvPr/>
-        </p:nvSpPr>
-        <p:spPr>
-          <a:xfrm>
-            <a:off x="628650" y="3219450"/>
-            <a:ext cx="4610100" cy="266700"/>
-          </a:xfrm>
-          <a:prstGeom prst="rect">
-            <a:avLst/>
-          </a:prstGeom>
-          <a:noFill/>
-        </p:spPr>
-        <p:txBody>
-          <a:bodyPr wrap="square">
-            <a:spAutoFit/>
-          </a:bodyPr>
-          <a:lstStyle/>
-          <a:p>
-            <a:pPr algn="ctr"/>
-            <a:r>
-              <a:rPr sz="1600" b="1">
-                <a:solidFill>
-                  <a:srgbClr val="0072B2"/>
-                </a:solidFill>
-                <a:latin typeface="Arial"/>
-                <a:ea typeface="AppleGothic"/>
-              </a:rPr>
-              <a:t>PP-X  |  식이 없거나 약할 때</a:t>
-            </a:r>
-          </a:p>
-        </p:txBody>
-      </p:sp>
-      <p:sp>
-        <p:nvSpPr>
-          <p:cNvPr id="21" name="TextBox 20"/>
-          <p:cNvSpPr txBox="1"/>
-          <p:nvPr/>
-        </p:nvSpPr>
-        <p:spPr>
-          <a:xfrm>
-            <a:off x="685800" y="3600450"/>
-            <a:ext cx="4495800" cy="628650"/>
-          </a:xfrm>
-          <a:prstGeom prst="rect">
-            <a:avLst/>
-          </a:prstGeom>
-          <a:noFill/>
-        </p:spPr>
-        <p:txBody>
-          <a:bodyPr wrap="square">
-            <a:spAutoFit/>
-          </a:bodyPr>
-          <a:lstStyle/>
-          <a:p>
-            <a:pPr algn="ctr"/>
-            <a:r>
-              <a:rPr sz="1200" b="0">
-                <a:solidFill>
-                  <a:srgbClr val="222222"/>
-                </a:solidFill>
-                <a:latin typeface="Arial"/>
-                <a:ea typeface="AppleGothic"/>
-              </a:rPr>
-              <a:t>weak prior + bounded residual</a:t>
+              <a:t>weak prior + residual candidate family</a:t>
             </a:r>
           </a:p>
           <a:p>
@@ -56682,7 +51874,7 @@
                 <a:latin typeface="Arial"/>
                 <a:ea typeface="AppleGothic"/>
               </a:rPr>
-              <a:t>prior + bounded</a:t>
+              <a:t>prior + residual</a:t>
             </a:r>
           </a:p>
           <a:p>
@@ -56695,7 +51887,7 @@
                 <a:latin typeface="Arial"/>
                 <a:ea typeface="AppleGothic"/>
               </a:rPr>
-              <a:t>residual 학습</a:t>
+              <a:t>후보 학습</a:t>
             </a:r>
           </a:p>
         </p:txBody>

</xml_diff>